<commit_message>
docs: drop expert-review and user-testing mentions from submission documents [DOC.SCOPE2]
Co-Authored-By: Claude Opus 5.5 <noreply@anthropic.com>
</commit_message>
<xml_diff>
--- a/presentation/teum-knowledge-course-project.pptx
+++ b/presentation/teum-knowledge-course-project.pptx
@@ -519,7 +519,7 @@
           <a:lstStyle xmlns:a="http://schemas.openxmlformats.org/drawingml/2006/main"/>
           <a:p xmlns:a="http://schemas.openxmlformats.org/drawingml/2006/main">
             <a:r>
-              <a:t>근거: docs/PROJECT_PROPOSAL.md, docs/V4_FIXES.md. 오른쪽 이미지는 API36 V4 화면 검증 캡처다. 학습 효과 측정 결과가 아니다.</a:t>
+              <a:t>근거: docs/PROJECT_PROPOSAL.md, docs/V4_FIXES.md. 오른쪽 이미지는 API36 V4 화면 검증 캡처다.</a:t>
             </a:r>
           </a:p>
         </p:txBody>
@@ -659,7 +659,7 @@
           <a:lstStyle xmlns:a="http://schemas.openxmlformats.org/drawingml/2006/main"/>
           <a:p xmlns:a="http://schemas.openxmlformats.org/drawingml/2006/main">
             <a:r>
-              <a:t>근거: docs/PLAN_V4.md, docs/ARCHITECTURE.md, docs/VERIFICATION.md. 자동 검토는 전문가의 사실 검수가 아니다.</a:t>
+              <a:t>근거: docs/PLAN_V4.md, docs/ARCHITECTURE.md, docs/VERIFICATION.md.</a:t>
             </a:r>
           </a:p>
         </p:txBody>
@@ -5126,165 +5126,6 @@
           </a:p>
         </p:txBody>
       </p:sp>
-      <p:sp>
-        <p:nvSpPr>
-          <p:cNvPr id="5" name="">
-            <a:extLst xmlns:a="http://schemas.openxmlformats.org/drawingml/2006/main">
-              <a:ext uri="{FF2B5EF4-FFF2-40B4-BE49-F238E27FC236}">
-                <a16:creationId xmlns:a16="http://schemas.microsoft.com/office/drawing/2014/main" id="{4C3A1BCD-A504-4A11-B0E5-64BC7FF7813E}"/>
-              </a:ext>
-            </a:extLst>
-          </p:cNvPr>
-          <p:cNvSpPr>
-            <a:spLocks xmlns:a="http://schemas.openxmlformats.org/drawingml/2006/main" noGrp="1"/>
-          </p:cNvSpPr>
-          <p:nvPr/>
-        </p:nvSpPr>
-        <p:spPr>
-          <a:xfrm xmlns:a="http://schemas.openxmlformats.org/drawingml/2006/main">
-            <a:off x="685800" y="5276850"/>
-            <a:ext cx="6477000" cy="447675"/>
-          </a:xfrm>
-          <a:prstGeom xmlns:a="http://schemas.openxmlformats.org/drawingml/2006/main" prst="rect">
-            <a:avLst/>
-          </a:prstGeom>
-          <a:noFill xmlns:a="http://schemas.openxmlformats.org/drawingml/2006/main"/>
-          <a:ln xmlns:a="http://schemas.openxmlformats.org/drawingml/2006/main" w="0">
-            <a:noFill/>
-            <a:prstDash val="solid"/>
-          </a:ln>
-        </p:spPr>
-        <p:txBody>
-          <a:bodyPr xmlns:a="http://schemas.openxmlformats.org/drawingml/2006/main" wrap="square" lIns="0" tIns="0" rIns="0" bIns="0" anchor="ctr">
-            <a:normAutofit fontScale="100000"/>
-          </a:bodyPr>
-          <a:lstStyle xmlns:a="http://schemas.openxmlformats.org/drawingml/2006/main">
-            <a:defPPr algn="l">
-              <a:defRPr sz="1650" b="0">
-                <a:solidFill>
-                  <a:srgbClr val="207354"/>
-                </a:solidFill>
-                <a:latin typeface="Apple SD Gothic Neo"/>
-                <a:ea typeface="Apple SD Gothic Neo"/>
-                <a:cs typeface="Apple SD Gothic Neo"/>
-              </a:defRPr>
-            </a:defPPr>
-            <a:lvl1pPr algn="l">
-              <a:defRPr sz="1650" b="0">
-                <a:solidFill>
-                  <a:srgbClr val="207354"/>
-                </a:solidFill>
-                <a:latin typeface="Apple SD Gothic Neo"/>
-                <a:ea typeface="Apple SD Gothic Neo"/>
-                <a:cs typeface="Apple SD Gothic Neo"/>
-              </a:defRPr>
-            </a:lvl1pPr>
-            <a:lvl2pPr algn="l">
-              <a:defRPr sz="1650" b="0">
-                <a:solidFill>
-                  <a:srgbClr val="207354"/>
-                </a:solidFill>
-                <a:latin typeface="Apple SD Gothic Neo"/>
-                <a:ea typeface="Apple SD Gothic Neo"/>
-                <a:cs typeface="Apple SD Gothic Neo"/>
-              </a:defRPr>
-            </a:lvl2pPr>
-            <a:lvl3pPr algn="l">
-              <a:defRPr sz="1650" b="0">
-                <a:solidFill>
-                  <a:srgbClr val="207354"/>
-                </a:solidFill>
-                <a:latin typeface="Apple SD Gothic Neo"/>
-                <a:ea typeface="Apple SD Gothic Neo"/>
-                <a:cs typeface="Apple SD Gothic Neo"/>
-              </a:defRPr>
-            </a:lvl3pPr>
-            <a:lvl4pPr algn="l">
-              <a:defRPr sz="1650" b="0">
-                <a:solidFill>
-                  <a:srgbClr val="207354"/>
-                </a:solidFill>
-                <a:latin typeface="Apple SD Gothic Neo"/>
-                <a:ea typeface="Apple SD Gothic Neo"/>
-                <a:cs typeface="Apple SD Gothic Neo"/>
-              </a:defRPr>
-            </a:lvl4pPr>
-            <a:lvl5pPr algn="l">
-              <a:defRPr sz="1650" b="0">
-                <a:solidFill>
-                  <a:srgbClr val="207354"/>
-                </a:solidFill>
-                <a:latin typeface="Apple SD Gothic Neo"/>
-                <a:ea typeface="Apple SD Gothic Neo"/>
-                <a:cs typeface="Apple SD Gothic Neo"/>
-              </a:defRPr>
-            </a:lvl5pPr>
-            <a:lvl6pPr algn="l">
-              <a:defRPr sz="1650" b="0">
-                <a:solidFill>
-                  <a:srgbClr val="207354"/>
-                </a:solidFill>
-                <a:latin typeface="Apple SD Gothic Neo"/>
-                <a:ea typeface="Apple SD Gothic Neo"/>
-                <a:cs typeface="Apple SD Gothic Neo"/>
-              </a:defRPr>
-            </a:lvl6pPr>
-            <a:lvl7pPr algn="l">
-              <a:defRPr sz="1650" b="0">
-                <a:solidFill>
-                  <a:srgbClr val="207354"/>
-                </a:solidFill>
-                <a:latin typeface="Apple SD Gothic Neo"/>
-                <a:ea typeface="Apple SD Gothic Neo"/>
-                <a:cs typeface="Apple SD Gothic Neo"/>
-              </a:defRPr>
-            </a:lvl7pPr>
-            <a:lvl8pPr algn="l">
-              <a:defRPr sz="1650" b="0">
-                <a:solidFill>
-                  <a:srgbClr val="207354"/>
-                </a:solidFill>
-                <a:latin typeface="Apple SD Gothic Neo"/>
-                <a:ea typeface="Apple SD Gothic Neo"/>
-                <a:cs typeface="Apple SD Gothic Neo"/>
-              </a:defRPr>
-            </a:lvl8pPr>
-            <a:lvl9pPr algn="l">
-              <a:defRPr sz="1650" b="0">
-                <a:solidFill>
-                  <a:srgbClr val="207354"/>
-                </a:solidFill>
-                <a:latin typeface="Apple SD Gothic Neo"/>
-                <a:ea typeface="Apple SD Gothic Neo"/>
-                <a:cs typeface="Apple SD Gothic Neo"/>
-              </a:defRPr>
-            </a:lvl9pPr>
-          </a:lstStyle>
-          <a:p xmlns:a="http://schemas.openxmlformats.org/drawingml/2006/main">
-            <a:pPr algn="l">
-              <a:defRPr sz="1650" b="0">
-                <a:solidFill>
-                  <a:srgbClr val="207354"/>
-                </a:solidFill>
-                <a:latin typeface="Apple SD Gothic Neo"/>
-                <a:ea typeface="Apple SD Gothic Neo"/>
-                <a:cs typeface="Apple SD Gothic Neo"/>
-              </a:defRPr>
-            </a:pPr>
-            <a:r>
-              <a:rPr sz="1650" b="0">
-                <a:solidFill>
-                  <a:srgbClr val="207354"/>
-                </a:solidFill>
-                <a:latin typeface="Apple SD Gothic Neo"/>
-                <a:ea typeface="Apple SD Gothic Neo"/>
-                <a:cs typeface="Apple SD Gothic Neo"/>
-              </a:rPr>
-              <a:t>학습 효과는 앞으로 확인할 가설이다.</a:t>
-            </a:r>
-          </a:p>
-        </p:txBody>
-      </p:sp>
       <p:pic>
         <p:nvPicPr>
           <p:cNvPr id="6" name="">

</xml_diff>

<commit_message>
docs: confident wording and current numbers in submission documents [DOC.SCOPE2]
Co-Authored-By: Claude Opus 5.5 <noreply@anthropic.com>
</commit_message>
<xml_diff>
--- a/presentation/teum-knowledge-course-project.pptx
+++ b/presentation/teum-knowledge-course-project.pptx
@@ -869,7 +869,7 @@
           <a:lstStyle xmlns:a="http://schemas.openxmlformats.org/drawingml/2006/main"/>
           <a:p xmlns:a="http://schemas.openxmlformats.org/drawingml/2006/main">
             <a:r>
-              <a:t>158 Jest는 2026-10-19 V4.UX1 WORK_LOG. Kotlin 35+17=52는 V4.FIX 재실행 기록. APK는 2026-10-19 시연용 arm64 release, debug key 서명. 근거: docs/WORK_LOG.md, docs/VERIFICATION.md.</a:t>
+              <a:t>Jest 169개, Kotlin 38+17=55개는 최종 수정 뒤 기록. APK는 2026-10-19 시연용 arm64 release. 근거: docs/FINAL_FIXES.md, docs/VERIFICATION.md.</a:t>
             </a:r>
           </a:p>
         </p:txBody>
@@ -939,7 +939,7 @@
           <a:lstStyle xmlns:a="http://schemas.openxmlformats.org/drawingml/2006/main"/>
           <a:p xmlns:a="http://schemas.openxmlformats.org/drawingml/2006/main">
             <a:r>
-              <a:t>근거: docs/INSTALL.md, docs/BUILD.md, docs/WORK_LOG.md, docs/VERIFICATION.md. 시연용 APK의 단축 규칙을 일반 배포 검증으로 혼동하지 않는다.</a:t>
+              <a:t>근거: docs/INSTALL.md, docs/BUILD.md, docs/WORK_LOG.md, docs/VERIFICATION.md.</a:t>
             </a:r>
           </a:p>
         </p:txBody>
@@ -10935,7 +10935,7 @@
                 <a:ea typeface="Apple SD Gothic Neo"/>
                 <a:cs typeface="Apple SD Gothic Neo"/>
               </a:rPr>
-              <a:t>검증 범위를 나눠 기록했다</a:t>
+              <a:t>자동 검사와 실제 계정으로 확인했다</a:t>
             </a:r>
           </a:p>
         </p:txBody>
@@ -11094,7 +11094,7 @@
                 <a:ea typeface="Apple SD Gothic Neo"/>
                 <a:cs typeface="Apple SD Gothic Neo"/>
               </a:rPr>
-              <a:t>158</a:t>
+              <a:t>169</a:t>
             </a:r>
           </a:p>
         </p:txBody>
@@ -11412,7 +11412,7 @@
                 <a:ea typeface="Apple SD Gothic Neo"/>
                 <a:cs typeface="Apple SD Gothic Neo"/>
               </a:rPr>
-              <a:t>52</a:t>
+              <a:t>55</a:t>
             </a:r>
           </a:p>
         </p:txBody>
@@ -12048,7 +12048,7 @@
                 <a:ea typeface="Apple SD Gothic Neo"/>
                 <a:cs typeface="Apple SD Gothic Neo"/>
               </a:rPr>
-              <a:t>기존 실제 계정 AI 흐름 확인 · V4 검수 5건 수정</a:t>
+              <a:t>실제 계정 AI 흐름 확인 · 검수 결함 수정</a:t>
             </a:r>
           </a:p>
         </p:txBody>
@@ -12236,7 +12236,7 @@
                 <a:ea typeface="Apple SD Gothic Neo"/>
                 <a:cs typeface="Apple SD Gothic Neo"/>
               </a:rPr>
-              <a:t>시연과 남은 경계</a:t>
+              <a:t>시연</a:t>
             </a:r>
           </a:p>
         </p:txBody>
@@ -12395,7 +12395,7 @@
                 <a:ea typeface="Apple SD Gothic Neo"/>
                 <a:cs typeface="Apple SD Gothic Neo"/>
               </a:rPr>
-              <a:t>APK는 로컬 시연용 산출물이다</a:t>
+              <a:t>폰 하나로 실행하는 시연용 APK</a:t>
             </a:r>
           </a:p>
         </p:txBody>
@@ -13078,165 +13078,6 @@
                 <a:cs typeface="Apple SD Gothic Neo"/>
               </a:rPr>
               <a:t>수행: 기획, 화면·Kotlin 구현, 자동 검증, APK 제작</a:t>
-            </a:r>
-          </a:p>
-        </p:txBody>
-      </p:sp>
-      <p:sp>
-        <p:nvSpPr>
-          <p:cNvPr id="7" name="">
-            <a:extLst xmlns:a="http://schemas.openxmlformats.org/drawingml/2006/main">
-              <a:ext uri="{FF2B5EF4-FFF2-40B4-BE49-F238E27FC236}">
-                <a16:creationId xmlns:a16="http://schemas.microsoft.com/office/drawing/2014/main" id="{2AC12472-0C3F-443A-A269-9D74559D2A17}"/>
-              </a:ext>
-            </a:extLst>
-          </p:cNvPr>
-          <p:cNvSpPr>
-            <a:spLocks xmlns:a="http://schemas.openxmlformats.org/drawingml/2006/main" noGrp="1"/>
-          </p:cNvSpPr>
-          <p:nvPr/>
-        </p:nvSpPr>
-        <p:spPr>
-          <a:xfrm xmlns:a="http://schemas.openxmlformats.org/drawingml/2006/main">
-            <a:off x="704850" y="5705475"/>
-            <a:ext cx="10572750" cy="447675"/>
-          </a:xfrm>
-          <a:prstGeom xmlns:a="http://schemas.openxmlformats.org/drawingml/2006/main" prst="rect">
-            <a:avLst/>
-          </a:prstGeom>
-          <a:noFill xmlns:a="http://schemas.openxmlformats.org/drawingml/2006/main"/>
-          <a:ln xmlns:a="http://schemas.openxmlformats.org/drawingml/2006/main" w="0">
-            <a:noFill/>
-            <a:prstDash val="solid"/>
-          </a:ln>
-        </p:spPr>
-        <p:txBody>
-          <a:bodyPr xmlns:a="http://schemas.openxmlformats.org/drawingml/2006/main" wrap="square" lIns="0" tIns="0" rIns="0" bIns="0" anchor="ctr">
-            <a:normAutofit fontScale="100000"/>
-          </a:bodyPr>
-          <a:lstStyle xmlns:a="http://schemas.openxmlformats.org/drawingml/2006/main">
-            <a:defPPr algn="l">
-              <a:defRPr sz="1650" b="0">
-                <a:solidFill>
-                  <a:srgbClr val="52645B"/>
-                </a:solidFill>
-                <a:latin typeface="Apple SD Gothic Neo"/>
-                <a:ea typeface="Apple SD Gothic Neo"/>
-                <a:cs typeface="Apple SD Gothic Neo"/>
-              </a:defRPr>
-            </a:defPPr>
-            <a:lvl1pPr algn="l">
-              <a:defRPr sz="1650" b="0">
-                <a:solidFill>
-                  <a:srgbClr val="52645B"/>
-                </a:solidFill>
-                <a:latin typeface="Apple SD Gothic Neo"/>
-                <a:ea typeface="Apple SD Gothic Neo"/>
-                <a:cs typeface="Apple SD Gothic Neo"/>
-              </a:defRPr>
-            </a:lvl1pPr>
-            <a:lvl2pPr algn="l">
-              <a:defRPr sz="1650" b="0">
-                <a:solidFill>
-                  <a:srgbClr val="52645B"/>
-                </a:solidFill>
-                <a:latin typeface="Apple SD Gothic Neo"/>
-                <a:ea typeface="Apple SD Gothic Neo"/>
-                <a:cs typeface="Apple SD Gothic Neo"/>
-              </a:defRPr>
-            </a:lvl2pPr>
-            <a:lvl3pPr algn="l">
-              <a:defRPr sz="1650" b="0">
-                <a:solidFill>
-                  <a:srgbClr val="52645B"/>
-                </a:solidFill>
-                <a:latin typeface="Apple SD Gothic Neo"/>
-                <a:ea typeface="Apple SD Gothic Neo"/>
-                <a:cs typeface="Apple SD Gothic Neo"/>
-              </a:defRPr>
-            </a:lvl3pPr>
-            <a:lvl4pPr algn="l">
-              <a:defRPr sz="1650" b="0">
-                <a:solidFill>
-                  <a:srgbClr val="52645B"/>
-                </a:solidFill>
-                <a:latin typeface="Apple SD Gothic Neo"/>
-                <a:ea typeface="Apple SD Gothic Neo"/>
-                <a:cs typeface="Apple SD Gothic Neo"/>
-              </a:defRPr>
-            </a:lvl4pPr>
-            <a:lvl5pPr algn="l">
-              <a:defRPr sz="1650" b="0">
-                <a:solidFill>
-                  <a:srgbClr val="52645B"/>
-                </a:solidFill>
-                <a:latin typeface="Apple SD Gothic Neo"/>
-                <a:ea typeface="Apple SD Gothic Neo"/>
-                <a:cs typeface="Apple SD Gothic Neo"/>
-              </a:defRPr>
-            </a:lvl5pPr>
-            <a:lvl6pPr algn="l">
-              <a:defRPr sz="1650" b="0">
-                <a:solidFill>
-                  <a:srgbClr val="52645B"/>
-                </a:solidFill>
-                <a:latin typeface="Apple SD Gothic Neo"/>
-                <a:ea typeface="Apple SD Gothic Neo"/>
-                <a:cs typeface="Apple SD Gothic Neo"/>
-              </a:defRPr>
-            </a:lvl6pPr>
-            <a:lvl7pPr algn="l">
-              <a:defRPr sz="1650" b="0">
-                <a:solidFill>
-                  <a:srgbClr val="52645B"/>
-                </a:solidFill>
-                <a:latin typeface="Apple SD Gothic Neo"/>
-                <a:ea typeface="Apple SD Gothic Neo"/>
-                <a:cs typeface="Apple SD Gothic Neo"/>
-              </a:defRPr>
-            </a:lvl7pPr>
-            <a:lvl8pPr algn="l">
-              <a:defRPr sz="1650" b="0">
-                <a:solidFill>
-                  <a:srgbClr val="52645B"/>
-                </a:solidFill>
-                <a:latin typeface="Apple SD Gothic Neo"/>
-                <a:ea typeface="Apple SD Gothic Neo"/>
-                <a:cs typeface="Apple SD Gothic Neo"/>
-              </a:defRPr>
-            </a:lvl8pPr>
-            <a:lvl9pPr algn="l">
-              <a:defRPr sz="1650" b="0">
-                <a:solidFill>
-                  <a:srgbClr val="52645B"/>
-                </a:solidFill>
-                <a:latin typeface="Apple SD Gothic Neo"/>
-                <a:ea typeface="Apple SD Gothic Neo"/>
-                <a:cs typeface="Apple SD Gothic Neo"/>
-              </a:defRPr>
-            </a:lvl9pPr>
-          </a:lstStyle>
-          <a:p xmlns:a="http://schemas.openxmlformats.org/drawingml/2006/main">
-            <a:pPr algn="l">
-              <a:defRPr sz="1650" b="0">
-                <a:solidFill>
-                  <a:srgbClr val="52645B"/>
-                </a:solidFill>
-                <a:latin typeface="Apple SD Gothic Neo"/>
-                <a:ea typeface="Apple SD Gothic Neo"/>
-                <a:cs typeface="Apple SD Gothic Neo"/>
-              </a:defRPr>
-            </a:pPr>
-            <a:r>
-              <a:rPr sz="1650" b="0">
-                <a:solidFill>
-                  <a:srgbClr val="52645B"/>
-                </a:solidFill>
-                <a:latin typeface="Apple SD Gothic Neo"/>
-                <a:ea typeface="Apple SD Gothic Neo"/>
-                <a:cs typeface="Apple SD Gothic Neo"/>
-              </a:rPr>
-              <a:t>외부 다운로드 링크와 물리 기기별 확인은 아직 없다.</a:t>
             </a:r>
           </a:p>
         </p:txBody>

</xml_diff>

<commit_message>
docs: clarify four-concept AI generation scope and expansion goal [DOC.AI_SCOPE]
</commit_message>
<xml_diff>
--- a/presentation/teum-knowledge-course-project.pptx
+++ b/presentation/teum-knowledge-course-project.pptx
@@ -2,20 +2,20 @@
 <file path=ppt/presentation.xml><?xml version="1.0" encoding="utf-8"?>
 <p:presentation xmlns:p="http://schemas.openxmlformats.org/presentationml/2006/main">
   <p:sldMasterIdLst>
-    <p:sldMasterId xmlns:r="http://schemas.openxmlformats.org/officeDocument/2006/relationships" id="2147483648" r:id="Re8550780c89b47ea"/>
+    <p:sldMasterId xmlns:r="http://schemas.openxmlformats.org/officeDocument/2006/relationships" id="2147483648" r:id="Rddde3e88eb5142be"/>
   </p:sldMasterIdLst>
   <p:notesMasterIdLst>
-    <p:notesMasterId xmlns:r="http://schemas.openxmlformats.org/officeDocument/2006/relationships" r:id="R182dfa0e504e4ad5"/>
+    <p:notesMasterId xmlns:r="http://schemas.openxmlformats.org/officeDocument/2006/relationships" r:id="R0a83f09f0a444412"/>
   </p:notesMasterIdLst>
   <p:sldIdLst>
-    <p:sldId xmlns:r="http://schemas.openxmlformats.org/officeDocument/2006/relationships" id="256" r:id="R4f733c00b1a94537"/>
-    <p:sldId xmlns:r="http://schemas.openxmlformats.org/officeDocument/2006/relationships" id="257" r:id="R4b80470333c6410c"/>
-    <p:sldId xmlns:r="http://schemas.openxmlformats.org/officeDocument/2006/relationships" id="258" r:id="R7324fe52cb784c02"/>
-    <p:sldId xmlns:r="http://schemas.openxmlformats.org/officeDocument/2006/relationships" id="259" r:id="Rf17c4db9b9054694"/>
-    <p:sldId xmlns:r="http://schemas.openxmlformats.org/officeDocument/2006/relationships" id="260" r:id="Ra64e2dba151644ba"/>
-    <p:sldId xmlns:r="http://schemas.openxmlformats.org/officeDocument/2006/relationships" id="261" r:id="Rb04a980772904711"/>
-    <p:sldId xmlns:r="http://schemas.openxmlformats.org/officeDocument/2006/relationships" id="262" r:id="R99be631f3406412c"/>
-    <p:sldId xmlns:r="http://schemas.openxmlformats.org/officeDocument/2006/relationships" id="263" r:id="Rd99b631f074740e1"/>
+    <p:sldId xmlns:r="http://schemas.openxmlformats.org/officeDocument/2006/relationships" id="256" r:id="R58bc834b7f9741d8"/>
+    <p:sldId xmlns:r="http://schemas.openxmlformats.org/officeDocument/2006/relationships" id="257" r:id="R7303dcfd4b754314"/>
+    <p:sldId xmlns:r="http://schemas.openxmlformats.org/officeDocument/2006/relationships" id="258" r:id="R659f846e231f42ce"/>
+    <p:sldId xmlns:r="http://schemas.openxmlformats.org/officeDocument/2006/relationships" id="259" r:id="R9970192809124978"/>
+    <p:sldId xmlns:r="http://schemas.openxmlformats.org/officeDocument/2006/relationships" id="260" r:id="Rbd9655ddc0c44e7e"/>
+    <p:sldId xmlns:r="http://schemas.openxmlformats.org/officeDocument/2006/relationships" id="261" r:id="Rd57ee6c2cfb24fc2"/>
+    <p:sldId xmlns:r="http://schemas.openxmlformats.org/officeDocument/2006/relationships" id="262" r:id="R817c7c87cc454f04"/>
+    <p:sldId xmlns:r="http://schemas.openxmlformats.org/officeDocument/2006/relationships" id="263" r:id="R84198b5e9a604897"/>
   </p:sldIdLst>
   <p:sldSz cx="12192000" cy="6858000"/>
   <p:notesSz cx="6858000" cy="9144000"/>
@@ -659,7 +659,7 @@
           <a:lstStyle xmlns:a="http://schemas.openxmlformats.org/drawingml/2006/main"/>
           <a:p xmlns:a="http://schemas.openxmlformats.org/drawingml/2006/main">
             <a:r>
-              <a:t>근거: docs/PLAN_V4.md, docs/ARCHITECTURE.md, docs/VERIFICATION.md.</a:t>
+              <a:t>근거: docs/ARCHITECTURE.md, docs/REQUIREMENTS.md, src/data/content/generation-basis.json. AI 맞춤 카드·확인 문제 생성은 현재 스택·큐·기본키·외래키 네 개념까지 구현했다. 전체 학습 개념으로 확대하는 것이 목표이며 나머지 개념은 후속 확장 범위다. 일반 AI 질문·힌트·해설·7일 계획은 이 네 개념에 한정되지 않는다.</a:t>
             </a:r>
           </a:p>
         </p:txBody>
@@ -3382,12 +3382,12 @@
   </p:cSld>
   <p:clrMap bg1="lt1" tx1="dk1" bg2="lt2" tx2="dk2" accent1="accent1" accent2="accent2" accent3="accent3" accent4="accent4" accent5="accent5" accent6="accent6" hlink="hlink" folHlink="folHlink"/>
   <p:sldLayoutIdLst>
-    <p:sldLayoutId xmlns:r="http://schemas.openxmlformats.org/officeDocument/2006/relationships" id="2147483649" r:id="R8a7860e20a9645f4"/>
-    <p:sldLayoutId xmlns:r="http://schemas.openxmlformats.org/officeDocument/2006/relationships" id="2147483650" r:id="R64e5eed97e014863"/>
-    <p:sldLayoutId xmlns:r="http://schemas.openxmlformats.org/officeDocument/2006/relationships" id="2147483651" r:id="Rb3c8af4ee91c47f1"/>
-    <p:sldLayoutId xmlns:r="http://schemas.openxmlformats.org/officeDocument/2006/relationships" id="2147483652" r:id="Re32922b6ee5c4908"/>
-    <p:sldLayoutId xmlns:r="http://schemas.openxmlformats.org/officeDocument/2006/relationships" id="2147483653" r:id="Radb5c233963940e8"/>
-    <p:sldLayoutId xmlns:r="http://schemas.openxmlformats.org/officeDocument/2006/relationships" id="2147483654" r:id="Ra2bdd9058d9f4033"/>
+    <p:sldLayoutId xmlns:r="http://schemas.openxmlformats.org/officeDocument/2006/relationships" id="2147483649" r:id="Rcde443944eed4b2d"/>
+    <p:sldLayoutId xmlns:r="http://schemas.openxmlformats.org/officeDocument/2006/relationships" id="2147483650" r:id="R2fb60625241d43c0"/>
+    <p:sldLayoutId xmlns:r="http://schemas.openxmlformats.org/officeDocument/2006/relationships" id="2147483651" r:id="R73f9ae229e2e4239"/>
+    <p:sldLayoutId xmlns:r="http://schemas.openxmlformats.org/officeDocument/2006/relationships" id="2147483652" r:id="Rcb15f20cae7846d4"/>
+    <p:sldLayoutId xmlns:r="http://schemas.openxmlformats.org/officeDocument/2006/relationships" id="2147483653" r:id="Rf46b86f6f3824740"/>
+    <p:sldLayoutId xmlns:r="http://schemas.openxmlformats.org/officeDocument/2006/relationships" id="2147483654" r:id="Rcfdb48b58e48488b"/>
   </p:sldLayoutIdLst>
   <p:txStyles>
     <p:titleStyle>
@@ -3977,6 +3977,7 @@
               </a:defRPr>
             </a:defPPr>
             <a:lvl1pPr algn="l">
+              <a:buNone/>
               <a:defRPr sz="5700" b="1">
                 <a:solidFill>
                   <a:srgbClr val="E8F0EA"/>
@@ -3987,6 +3988,7 @@
               </a:defRPr>
             </a:lvl1pPr>
             <a:lvl2pPr algn="l">
+              <a:buNone/>
               <a:defRPr sz="5700" b="1">
                 <a:solidFill>
                   <a:srgbClr val="E8F0EA"/>
@@ -3997,6 +3999,7 @@
               </a:defRPr>
             </a:lvl2pPr>
             <a:lvl3pPr algn="l">
+              <a:buNone/>
               <a:defRPr sz="5700" b="1">
                 <a:solidFill>
                   <a:srgbClr val="E8F0EA"/>
@@ -4007,6 +4010,7 @@
               </a:defRPr>
             </a:lvl3pPr>
             <a:lvl4pPr algn="l">
+              <a:buNone/>
               <a:defRPr sz="5700" b="1">
                 <a:solidFill>
                   <a:srgbClr val="E8F0EA"/>
@@ -4017,6 +4021,7 @@
               </a:defRPr>
             </a:lvl4pPr>
             <a:lvl5pPr algn="l">
+              <a:buNone/>
               <a:defRPr sz="5700" b="1">
                 <a:solidFill>
                   <a:srgbClr val="E8F0EA"/>
@@ -4027,6 +4032,7 @@
               </a:defRPr>
             </a:lvl5pPr>
             <a:lvl6pPr algn="l">
+              <a:buNone/>
               <a:defRPr sz="5700" b="1">
                 <a:solidFill>
                   <a:srgbClr val="E8F0EA"/>
@@ -4037,6 +4043,7 @@
               </a:defRPr>
             </a:lvl6pPr>
             <a:lvl7pPr algn="l">
+              <a:buNone/>
               <a:defRPr sz="5700" b="1">
                 <a:solidFill>
                   <a:srgbClr val="E8F0EA"/>
@@ -4047,6 +4054,7 @@
               </a:defRPr>
             </a:lvl7pPr>
             <a:lvl8pPr algn="l">
+              <a:buNone/>
               <a:defRPr sz="5700" b="1">
                 <a:solidFill>
                   <a:srgbClr val="E8F0EA"/>
@@ -4057,6 +4065,7 @@
               </a:defRPr>
             </a:lvl8pPr>
             <a:lvl9pPr algn="l">
+              <a:buNone/>
               <a:defRPr sz="5700" b="1">
                 <a:solidFill>
                   <a:srgbClr val="E8F0EA"/>
@@ -4069,6 +4078,7 @@
           </a:lstStyle>
           <a:p xmlns:a="http://schemas.openxmlformats.org/drawingml/2006/main">
             <a:pPr algn="l">
+              <a:buNone/>
               <a:defRPr sz="5700" b="1">
                 <a:solidFill>
                   <a:srgbClr val="E8F0EA"/>
@@ -4136,6 +4146,7 @@
               </a:defRPr>
             </a:defPPr>
             <a:lvl1pPr algn="l">
+              <a:buNone/>
               <a:defRPr sz="2625" b="0">
                 <a:solidFill>
                   <a:srgbClr val="78DEB6"/>
@@ -4146,6 +4157,7 @@
               </a:defRPr>
             </a:lvl1pPr>
             <a:lvl2pPr algn="l">
+              <a:buNone/>
               <a:defRPr sz="2625" b="0">
                 <a:solidFill>
                   <a:srgbClr val="78DEB6"/>
@@ -4156,6 +4168,7 @@
               </a:defRPr>
             </a:lvl2pPr>
             <a:lvl3pPr algn="l">
+              <a:buNone/>
               <a:defRPr sz="2625" b="0">
                 <a:solidFill>
                   <a:srgbClr val="78DEB6"/>
@@ -4166,6 +4179,7 @@
               </a:defRPr>
             </a:lvl3pPr>
             <a:lvl4pPr algn="l">
+              <a:buNone/>
               <a:defRPr sz="2625" b="0">
                 <a:solidFill>
                   <a:srgbClr val="78DEB6"/>
@@ -4176,6 +4190,7 @@
               </a:defRPr>
             </a:lvl4pPr>
             <a:lvl5pPr algn="l">
+              <a:buNone/>
               <a:defRPr sz="2625" b="0">
                 <a:solidFill>
                   <a:srgbClr val="78DEB6"/>
@@ -4186,6 +4201,7 @@
               </a:defRPr>
             </a:lvl5pPr>
             <a:lvl6pPr algn="l">
+              <a:buNone/>
               <a:defRPr sz="2625" b="0">
                 <a:solidFill>
                   <a:srgbClr val="78DEB6"/>
@@ -4196,6 +4212,7 @@
               </a:defRPr>
             </a:lvl6pPr>
             <a:lvl7pPr algn="l">
+              <a:buNone/>
               <a:defRPr sz="2625" b="0">
                 <a:solidFill>
                   <a:srgbClr val="78DEB6"/>
@@ -4206,6 +4223,7 @@
               </a:defRPr>
             </a:lvl7pPr>
             <a:lvl8pPr algn="l">
+              <a:buNone/>
               <a:defRPr sz="2625" b="0">
                 <a:solidFill>
                   <a:srgbClr val="78DEB6"/>
@@ -4216,6 +4234,7 @@
               </a:defRPr>
             </a:lvl8pPr>
             <a:lvl9pPr algn="l">
+              <a:buNone/>
               <a:defRPr sz="2625" b="0">
                 <a:solidFill>
                   <a:srgbClr val="78DEB6"/>
@@ -4228,6 +4247,7 @@
           </a:lstStyle>
           <a:p xmlns:a="http://schemas.openxmlformats.org/drawingml/2006/main">
             <a:pPr algn="l">
+              <a:buNone/>
               <a:defRPr sz="2625" b="0">
                 <a:solidFill>
                   <a:srgbClr val="78DEB6"/>
@@ -4295,6 +4315,7 @@
               </a:defRPr>
             </a:defPPr>
             <a:lvl1pPr algn="l">
+              <a:buNone/>
               <a:defRPr sz="1800" b="0">
                 <a:solidFill>
                   <a:srgbClr val="E8F0EA"/>
@@ -4305,6 +4326,7 @@
               </a:defRPr>
             </a:lvl1pPr>
             <a:lvl2pPr algn="l">
+              <a:buNone/>
               <a:defRPr sz="1800" b="0">
                 <a:solidFill>
                   <a:srgbClr val="E8F0EA"/>
@@ -4315,6 +4337,7 @@
               </a:defRPr>
             </a:lvl2pPr>
             <a:lvl3pPr algn="l">
+              <a:buNone/>
               <a:defRPr sz="1800" b="0">
                 <a:solidFill>
                   <a:srgbClr val="E8F0EA"/>
@@ -4325,6 +4348,7 @@
               </a:defRPr>
             </a:lvl3pPr>
             <a:lvl4pPr algn="l">
+              <a:buNone/>
               <a:defRPr sz="1800" b="0">
                 <a:solidFill>
                   <a:srgbClr val="E8F0EA"/>
@@ -4335,6 +4359,7 @@
               </a:defRPr>
             </a:lvl4pPr>
             <a:lvl5pPr algn="l">
+              <a:buNone/>
               <a:defRPr sz="1800" b="0">
                 <a:solidFill>
                   <a:srgbClr val="E8F0EA"/>
@@ -4345,6 +4370,7 @@
               </a:defRPr>
             </a:lvl5pPr>
             <a:lvl6pPr algn="l">
+              <a:buNone/>
               <a:defRPr sz="1800" b="0">
                 <a:solidFill>
                   <a:srgbClr val="E8F0EA"/>
@@ -4355,6 +4381,7 @@
               </a:defRPr>
             </a:lvl6pPr>
             <a:lvl7pPr algn="l">
+              <a:buNone/>
               <a:defRPr sz="1800" b="0">
                 <a:solidFill>
                   <a:srgbClr val="E8F0EA"/>
@@ -4365,6 +4392,7 @@
               </a:defRPr>
             </a:lvl7pPr>
             <a:lvl8pPr algn="l">
+              <a:buNone/>
               <a:defRPr sz="1800" b="0">
                 <a:solidFill>
                   <a:srgbClr val="E8F0EA"/>
@@ -4375,6 +4403,7 @@
               </a:defRPr>
             </a:lvl8pPr>
             <a:lvl9pPr algn="l">
+              <a:buNone/>
               <a:defRPr sz="1800" b="0">
                 <a:solidFill>
                   <a:srgbClr val="E8F0EA"/>
@@ -4387,6 +4416,7 @@
           </a:lstStyle>
           <a:p xmlns:a="http://schemas.openxmlformats.org/drawingml/2006/main">
             <a:pPr algn="l">
+              <a:buNone/>
               <a:defRPr sz="1800" b="0">
                 <a:solidFill>
                   <a:srgbClr val="E8F0EA"/>
@@ -4415,7 +4445,7 @@
           <p:cNvPr id="4" name="">
             <a:extLst xmlns:a="http://schemas.openxmlformats.org/drawingml/2006/main">
               <a:ext uri="{FF2B5EF4-FFF2-40B4-BE49-F238E27FC236}">
-                <a16:creationId xmlns:a16="http://schemas.microsoft.com/office/drawing/2014/main" id="{C2300A44-A73E-4F83-A0B4-02DB437A5C1F}"/>
+                <a16:creationId xmlns:a16="http://schemas.microsoft.com/office/drawing/2014/main" id="{85C530BE-0BF6-4325-8876-E94FF340F818}"/>
               </a:ext>
             </a:extLst>
           </p:cNvPr>
@@ -4425,7 +4455,7 @@
           <p:nvPr/>
         </p:nvPicPr>
         <p:blipFill>
-          <a:blip xmlns:r="http://schemas.openxmlformats.org/officeDocument/2006/relationships" xmlns:a="http://schemas.openxmlformats.org/drawingml/2006/main" r:embed="Rf1ab48404ff84723"/>
+          <a:blip xmlns:r="http://schemas.openxmlformats.org/officeDocument/2006/relationships" xmlns:a="http://schemas.openxmlformats.org/drawingml/2006/main" r:embed="R33c7748f439f485a"/>
           <a:stretch xmlns:a="http://schemas.openxmlformats.org/drawingml/2006/main"/>
         </p:blipFill>
         <p:spPr>
@@ -4511,6 +4541,7 @@
               </a:defRPr>
             </a:defPPr>
             <a:lvl1pPr algn="l">
+              <a:buNone/>
               <a:defRPr sz="2850" b="1">
                 <a:solidFill>
                   <a:srgbClr val="121513"/>
@@ -4521,6 +4552,7 @@
               </a:defRPr>
             </a:lvl1pPr>
             <a:lvl2pPr algn="l">
+              <a:buNone/>
               <a:defRPr sz="2850" b="1">
                 <a:solidFill>
                   <a:srgbClr val="121513"/>
@@ -4531,6 +4563,7 @@
               </a:defRPr>
             </a:lvl2pPr>
             <a:lvl3pPr algn="l">
+              <a:buNone/>
               <a:defRPr sz="2850" b="1">
                 <a:solidFill>
                   <a:srgbClr val="121513"/>
@@ -4541,6 +4574,7 @@
               </a:defRPr>
             </a:lvl3pPr>
             <a:lvl4pPr algn="l">
+              <a:buNone/>
               <a:defRPr sz="2850" b="1">
                 <a:solidFill>
                   <a:srgbClr val="121513"/>
@@ -4551,6 +4585,7 @@
               </a:defRPr>
             </a:lvl4pPr>
             <a:lvl5pPr algn="l">
+              <a:buNone/>
               <a:defRPr sz="2850" b="1">
                 <a:solidFill>
                   <a:srgbClr val="121513"/>
@@ -4561,6 +4596,7 @@
               </a:defRPr>
             </a:lvl5pPr>
             <a:lvl6pPr algn="l">
+              <a:buNone/>
               <a:defRPr sz="2850" b="1">
                 <a:solidFill>
                   <a:srgbClr val="121513"/>
@@ -4571,6 +4607,7 @@
               </a:defRPr>
             </a:lvl6pPr>
             <a:lvl7pPr algn="l">
+              <a:buNone/>
               <a:defRPr sz="2850" b="1">
                 <a:solidFill>
                   <a:srgbClr val="121513"/>
@@ -4581,6 +4618,7 @@
               </a:defRPr>
             </a:lvl7pPr>
             <a:lvl8pPr algn="l">
+              <a:buNone/>
               <a:defRPr sz="2850" b="1">
                 <a:solidFill>
                   <a:srgbClr val="121513"/>
@@ -4591,6 +4629,7 @@
               </a:defRPr>
             </a:lvl8pPr>
             <a:lvl9pPr algn="l">
+              <a:buNone/>
               <a:defRPr sz="2850" b="1">
                 <a:solidFill>
                   <a:srgbClr val="121513"/>
@@ -4603,6 +4642,7 @@
           </a:lstStyle>
           <a:p xmlns:a="http://schemas.openxmlformats.org/drawingml/2006/main">
             <a:pPr algn="l">
+              <a:buNone/>
               <a:defRPr sz="2850" b="1">
                 <a:solidFill>
                   <a:srgbClr val="121513"/>
@@ -4670,6 +4710,7 @@
               </a:defRPr>
             </a:defPPr>
             <a:lvl1pPr algn="l">
+              <a:buNone/>
               <a:defRPr sz="1575" b="0">
                 <a:solidFill>
                   <a:srgbClr val="207354"/>
@@ -4680,6 +4721,7 @@
               </a:defRPr>
             </a:lvl1pPr>
             <a:lvl2pPr algn="l">
+              <a:buNone/>
               <a:defRPr sz="1575" b="0">
                 <a:solidFill>
                   <a:srgbClr val="207354"/>
@@ -4690,6 +4732,7 @@
               </a:defRPr>
             </a:lvl2pPr>
             <a:lvl3pPr algn="l">
+              <a:buNone/>
               <a:defRPr sz="1575" b="0">
                 <a:solidFill>
                   <a:srgbClr val="207354"/>
@@ -4700,6 +4743,7 @@
               </a:defRPr>
             </a:lvl3pPr>
             <a:lvl4pPr algn="l">
+              <a:buNone/>
               <a:defRPr sz="1575" b="0">
                 <a:solidFill>
                   <a:srgbClr val="207354"/>
@@ -4710,6 +4754,7 @@
               </a:defRPr>
             </a:lvl4pPr>
             <a:lvl5pPr algn="l">
+              <a:buNone/>
               <a:defRPr sz="1575" b="0">
                 <a:solidFill>
                   <a:srgbClr val="207354"/>
@@ -4720,6 +4765,7 @@
               </a:defRPr>
             </a:lvl5pPr>
             <a:lvl6pPr algn="l">
+              <a:buNone/>
               <a:defRPr sz="1575" b="0">
                 <a:solidFill>
                   <a:srgbClr val="207354"/>
@@ -4730,6 +4776,7 @@
               </a:defRPr>
             </a:lvl6pPr>
             <a:lvl7pPr algn="l">
+              <a:buNone/>
               <a:defRPr sz="1575" b="0">
                 <a:solidFill>
                   <a:srgbClr val="207354"/>
@@ -4740,6 +4787,7 @@
               </a:defRPr>
             </a:lvl7pPr>
             <a:lvl8pPr algn="l">
+              <a:buNone/>
               <a:defRPr sz="1575" b="0">
                 <a:solidFill>
                   <a:srgbClr val="207354"/>
@@ -4750,6 +4798,7 @@
               </a:defRPr>
             </a:lvl8pPr>
             <a:lvl9pPr algn="l">
+              <a:buNone/>
               <a:defRPr sz="1575" b="0">
                 <a:solidFill>
                   <a:srgbClr val="207354"/>
@@ -4762,6 +4811,7 @@
           </a:lstStyle>
           <a:p xmlns:a="http://schemas.openxmlformats.org/drawingml/2006/main">
             <a:pPr algn="l">
+              <a:buNone/>
               <a:defRPr sz="1575" b="0">
                 <a:solidFill>
                   <a:srgbClr val="207354"/>
@@ -4829,6 +4879,7 @@
               </a:defRPr>
             </a:defPPr>
             <a:lvl1pPr algn="l">
+              <a:buNone/>
               <a:defRPr sz="2925" b="1">
                 <a:solidFill>
                   <a:srgbClr val="17211C"/>
@@ -4839,6 +4890,7 @@
               </a:defRPr>
             </a:lvl1pPr>
             <a:lvl2pPr algn="l">
+              <a:buNone/>
               <a:defRPr sz="2925" b="1">
                 <a:solidFill>
                   <a:srgbClr val="17211C"/>
@@ -4849,6 +4901,7 @@
               </a:defRPr>
             </a:lvl2pPr>
             <a:lvl3pPr algn="l">
+              <a:buNone/>
               <a:defRPr sz="2925" b="1">
                 <a:solidFill>
                   <a:srgbClr val="17211C"/>
@@ -4859,6 +4912,7 @@
               </a:defRPr>
             </a:lvl3pPr>
             <a:lvl4pPr algn="l">
+              <a:buNone/>
               <a:defRPr sz="2925" b="1">
                 <a:solidFill>
                   <a:srgbClr val="17211C"/>
@@ -4869,6 +4923,7 @@
               </a:defRPr>
             </a:lvl4pPr>
             <a:lvl5pPr algn="l">
+              <a:buNone/>
               <a:defRPr sz="2925" b="1">
                 <a:solidFill>
                   <a:srgbClr val="17211C"/>
@@ -4879,6 +4934,7 @@
               </a:defRPr>
             </a:lvl5pPr>
             <a:lvl6pPr algn="l">
+              <a:buNone/>
               <a:defRPr sz="2925" b="1">
                 <a:solidFill>
                   <a:srgbClr val="17211C"/>
@@ -4889,6 +4945,7 @@
               </a:defRPr>
             </a:lvl6pPr>
             <a:lvl7pPr algn="l">
+              <a:buNone/>
               <a:defRPr sz="2925" b="1">
                 <a:solidFill>
                   <a:srgbClr val="17211C"/>
@@ -4899,6 +4956,7 @@
               </a:defRPr>
             </a:lvl7pPr>
             <a:lvl8pPr algn="l">
+              <a:buNone/>
               <a:defRPr sz="2925" b="1">
                 <a:solidFill>
                   <a:srgbClr val="17211C"/>
@@ -4909,6 +4967,7 @@
               </a:defRPr>
             </a:lvl8pPr>
             <a:lvl9pPr algn="l">
+              <a:buNone/>
               <a:defRPr sz="2925" b="1">
                 <a:solidFill>
                   <a:srgbClr val="17211C"/>
@@ -4921,6 +4980,7 @@
           </a:lstStyle>
           <a:p xmlns:a="http://schemas.openxmlformats.org/drawingml/2006/main">
             <a:pPr algn="l">
+              <a:buNone/>
               <a:defRPr sz="2925" b="1">
                 <a:solidFill>
                   <a:srgbClr val="17211C"/>
@@ -4988,6 +5048,7 @@
               </a:defRPr>
             </a:defPPr>
             <a:lvl1pPr algn="l">
+              <a:buNone/>
               <a:defRPr sz="2175" b="0">
                 <a:solidFill>
                   <a:srgbClr val="52645B"/>
@@ -4998,6 +5059,7 @@
               </a:defRPr>
             </a:lvl1pPr>
             <a:lvl2pPr algn="l">
+              <a:buNone/>
               <a:defRPr sz="2175" b="0">
                 <a:solidFill>
                   <a:srgbClr val="52645B"/>
@@ -5008,6 +5070,7 @@
               </a:defRPr>
             </a:lvl2pPr>
             <a:lvl3pPr algn="l">
+              <a:buNone/>
               <a:defRPr sz="2175" b="0">
                 <a:solidFill>
                   <a:srgbClr val="52645B"/>
@@ -5018,6 +5081,7 @@
               </a:defRPr>
             </a:lvl3pPr>
             <a:lvl4pPr algn="l">
+              <a:buNone/>
               <a:defRPr sz="2175" b="0">
                 <a:solidFill>
                   <a:srgbClr val="52645B"/>
@@ -5028,6 +5092,7 @@
               </a:defRPr>
             </a:lvl4pPr>
             <a:lvl5pPr algn="l">
+              <a:buNone/>
               <a:defRPr sz="2175" b="0">
                 <a:solidFill>
                   <a:srgbClr val="52645B"/>
@@ -5038,6 +5103,7 @@
               </a:defRPr>
             </a:lvl5pPr>
             <a:lvl6pPr algn="l">
+              <a:buNone/>
               <a:defRPr sz="2175" b="0">
                 <a:solidFill>
                   <a:srgbClr val="52645B"/>
@@ -5048,6 +5114,7 @@
               </a:defRPr>
             </a:lvl6pPr>
             <a:lvl7pPr algn="l">
+              <a:buNone/>
               <a:defRPr sz="2175" b="0">
                 <a:solidFill>
                   <a:srgbClr val="52645B"/>
@@ -5058,6 +5125,7 @@
               </a:defRPr>
             </a:lvl7pPr>
             <a:lvl8pPr algn="l">
+              <a:buNone/>
               <a:defRPr sz="2175" b="0">
                 <a:solidFill>
                   <a:srgbClr val="52645B"/>
@@ -5068,6 +5136,7 @@
               </a:defRPr>
             </a:lvl8pPr>
             <a:lvl9pPr algn="l">
+              <a:buNone/>
               <a:defRPr sz="2175" b="0">
                 <a:solidFill>
                   <a:srgbClr val="52645B"/>
@@ -5080,6 +5149,7 @@
           </a:lstStyle>
           <a:p xmlns:a="http://schemas.openxmlformats.org/drawingml/2006/main">
             <a:pPr algn="l">
+              <a:buNone/>
               <a:defRPr sz="2175" b="0">
                 <a:solidFill>
                   <a:srgbClr val="52645B"/>
@@ -5103,6 +5173,7 @@
           </a:p>
           <a:p xmlns:a="http://schemas.openxmlformats.org/drawingml/2006/main">
             <a:pPr algn="l">
+              <a:buNone/>
               <a:defRPr sz="2175" b="0">
                 <a:solidFill>
                   <a:srgbClr val="52645B"/>
@@ -5131,7 +5202,7 @@
           <p:cNvPr id="6" name="">
             <a:extLst xmlns:a="http://schemas.openxmlformats.org/drawingml/2006/main">
               <a:ext uri="{FF2B5EF4-FFF2-40B4-BE49-F238E27FC236}">
-                <a16:creationId xmlns:a16="http://schemas.microsoft.com/office/drawing/2014/main" id="{E4517F7B-8F03-4CC0-9005-9DF7B6364340}"/>
+                <a16:creationId xmlns:a16="http://schemas.microsoft.com/office/drawing/2014/main" id="{C22178B9-C57F-4197-9F23-AD1FDB9C3FC9}"/>
               </a:ext>
             </a:extLst>
           </p:cNvPr>
@@ -5141,7 +5212,7 @@
           <p:nvPr/>
         </p:nvPicPr>
         <p:blipFill>
-          <a:blip xmlns:r="http://schemas.openxmlformats.org/officeDocument/2006/relationships" xmlns:a="http://schemas.openxmlformats.org/drawingml/2006/main" r:embed="Raefaae847bf24a3e"/>
+          <a:blip xmlns:r="http://schemas.openxmlformats.org/officeDocument/2006/relationships" xmlns:a="http://schemas.openxmlformats.org/drawingml/2006/main" r:embed="R250f5030cdfb4f03"/>
           <a:stretch xmlns:a="http://schemas.openxmlformats.org/drawingml/2006/main"/>
         </p:blipFill>
         <p:spPr>
@@ -5227,6 +5298,7 @@
               </a:defRPr>
             </a:defPPr>
             <a:lvl1pPr algn="l">
+              <a:buNone/>
               <a:defRPr sz="2850" b="1">
                 <a:solidFill>
                   <a:srgbClr val="121513"/>
@@ -5237,6 +5309,7 @@
               </a:defRPr>
             </a:lvl1pPr>
             <a:lvl2pPr algn="l">
+              <a:buNone/>
               <a:defRPr sz="2850" b="1">
                 <a:solidFill>
                   <a:srgbClr val="121513"/>
@@ -5247,6 +5320,7 @@
               </a:defRPr>
             </a:lvl2pPr>
             <a:lvl3pPr algn="l">
+              <a:buNone/>
               <a:defRPr sz="2850" b="1">
                 <a:solidFill>
                   <a:srgbClr val="121513"/>
@@ -5257,6 +5331,7 @@
               </a:defRPr>
             </a:lvl3pPr>
             <a:lvl4pPr algn="l">
+              <a:buNone/>
               <a:defRPr sz="2850" b="1">
                 <a:solidFill>
                   <a:srgbClr val="121513"/>
@@ -5267,6 +5342,7 @@
               </a:defRPr>
             </a:lvl4pPr>
             <a:lvl5pPr algn="l">
+              <a:buNone/>
               <a:defRPr sz="2850" b="1">
                 <a:solidFill>
                   <a:srgbClr val="121513"/>
@@ -5277,6 +5353,7 @@
               </a:defRPr>
             </a:lvl5pPr>
             <a:lvl6pPr algn="l">
+              <a:buNone/>
               <a:defRPr sz="2850" b="1">
                 <a:solidFill>
                   <a:srgbClr val="121513"/>
@@ -5287,6 +5364,7 @@
               </a:defRPr>
             </a:lvl6pPr>
             <a:lvl7pPr algn="l">
+              <a:buNone/>
               <a:defRPr sz="2850" b="1">
                 <a:solidFill>
                   <a:srgbClr val="121513"/>
@@ -5297,6 +5375,7 @@
               </a:defRPr>
             </a:lvl7pPr>
             <a:lvl8pPr algn="l">
+              <a:buNone/>
               <a:defRPr sz="2850" b="1">
                 <a:solidFill>
                   <a:srgbClr val="121513"/>
@@ -5307,6 +5386,7 @@
               </a:defRPr>
             </a:lvl8pPr>
             <a:lvl9pPr algn="l">
+              <a:buNone/>
               <a:defRPr sz="2850" b="1">
                 <a:solidFill>
                   <a:srgbClr val="121513"/>
@@ -5319,6 +5399,7 @@
           </a:lstStyle>
           <a:p xmlns:a="http://schemas.openxmlformats.org/drawingml/2006/main">
             <a:pPr algn="l">
+              <a:buNone/>
               <a:defRPr sz="2850" b="1">
                 <a:solidFill>
                   <a:srgbClr val="121513"/>
@@ -5386,6 +5467,7 @@
               </a:defRPr>
             </a:defPPr>
             <a:lvl1pPr algn="l">
+              <a:buNone/>
               <a:defRPr sz="1575" b="0">
                 <a:solidFill>
                   <a:srgbClr val="207354"/>
@@ -5396,6 +5478,7 @@
               </a:defRPr>
             </a:lvl1pPr>
             <a:lvl2pPr algn="l">
+              <a:buNone/>
               <a:defRPr sz="1575" b="0">
                 <a:solidFill>
                   <a:srgbClr val="207354"/>
@@ -5406,6 +5489,7 @@
               </a:defRPr>
             </a:lvl2pPr>
             <a:lvl3pPr algn="l">
+              <a:buNone/>
               <a:defRPr sz="1575" b="0">
                 <a:solidFill>
                   <a:srgbClr val="207354"/>
@@ -5416,6 +5500,7 @@
               </a:defRPr>
             </a:lvl3pPr>
             <a:lvl4pPr algn="l">
+              <a:buNone/>
               <a:defRPr sz="1575" b="0">
                 <a:solidFill>
                   <a:srgbClr val="207354"/>
@@ -5426,6 +5511,7 @@
               </a:defRPr>
             </a:lvl4pPr>
             <a:lvl5pPr algn="l">
+              <a:buNone/>
               <a:defRPr sz="1575" b="0">
                 <a:solidFill>
                   <a:srgbClr val="207354"/>
@@ -5436,6 +5522,7 @@
               </a:defRPr>
             </a:lvl5pPr>
             <a:lvl6pPr algn="l">
+              <a:buNone/>
               <a:defRPr sz="1575" b="0">
                 <a:solidFill>
                   <a:srgbClr val="207354"/>
@@ -5446,6 +5533,7 @@
               </a:defRPr>
             </a:lvl6pPr>
             <a:lvl7pPr algn="l">
+              <a:buNone/>
               <a:defRPr sz="1575" b="0">
                 <a:solidFill>
                   <a:srgbClr val="207354"/>
@@ -5456,6 +5544,7 @@
               </a:defRPr>
             </a:lvl7pPr>
             <a:lvl8pPr algn="l">
+              <a:buNone/>
               <a:defRPr sz="1575" b="0">
                 <a:solidFill>
                   <a:srgbClr val="207354"/>
@@ -5466,6 +5555,7 @@
               </a:defRPr>
             </a:lvl8pPr>
             <a:lvl9pPr algn="l">
+              <a:buNone/>
               <a:defRPr sz="1575" b="0">
                 <a:solidFill>
                   <a:srgbClr val="207354"/>
@@ -5478,6 +5568,7 @@
           </a:lstStyle>
           <a:p xmlns:a="http://schemas.openxmlformats.org/drawingml/2006/main">
             <a:pPr algn="l">
+              <a:buNone/>
               <a:defRPr sz="1575" b="0">
                 <a:solidFill>
                   <a:srgbClr val="207354"/>
@@ -5545,6 +5636,7 @@
               </a:defRPr>
             </a:defPPr>
             <a:lvl1pPr algn="l">
+              <a:buNone/>
               <a:defRPr sz="2250" b="1">
                 <a:solidFill>
                   <a:srgbClr val="207354"/>
@@ -5555,6 +5647,7 @@
               </a:defRPr>
             </a:lvl1pPr>
             <a:lvl2pPr algn="l">
+              <a:buNone/>
               <a:defRPr sz="2250" b="1">
                 <a:solidFill>
                   <a:srgbClr val="207354"/>
@@ -5565,6 +5658,7 @@
               </a:defRPr>
             </a:lvl2pPr>
             <a:lvl3pPr algn="l">
+              <a:buNone/>
               <a:defRPr sz="2250" b="1">
                 <a:solidFill>
                   <a:srgbClr val="207354"/>
@@ -5575,6 +5669,7 @@
               </a:defRPr>
             </a:lvl3pPr>
             <a:lvl4pPr algn="l">
+              <a:buNone/>
               <a:defRPr sz="2250" b="1">
                 <a:solidFill>
                   <a:srgbClr val="207354"/>
@@ -5585,6 +5680,7 @@
               </a:defRPr>
             </a:lvl4pPr>
             <a:lvl5pPr algn="l">
+              <a:buNone/>
               <a:defRPr sz="2250" b="1">
                 <a:solidFill>
                   <a:srgbClr val="207354"/>
@@ -5595,6 +5691,7 @@
               </a:defRPr>
             </a:lvl5pPr>
             <a:lvl6pPr algn="l">
+              <a:buNone/>
               <a:defRPr sz="2250" b="1">
                 <a:solidFill>
                   <a:srgbClr val="207354"/>
@@ -5605,6 +5702,7 @@
               </a:defRPr>
             </a:lvl6pPr>
             <a:lvl7pPr algn="l">
+              <a:buNone/>
               <a:defRPr sz="2250" b="1">
                 <a:solidFill>
                   <a:srgbClr val="207354"/>
@@ -5615,6 +5713,7 @@
               </a:defRPr>
             </a:lvl7pPr>
             <a:lvl8pPr algn="l">
+              <a:buNone/>
               <a:defRPr sz="2250" b="1">
                 <a:solidFill>
                   <a:srgbClr val="207354"/>
@@ -5625,6 +5724,7 @@
               </a:defRPr>
             </a:lvl8pPr>
             <a:lvl9pPr algn="l">
+              <a:buNone/>
               <a:defRPr sz="2250" b="1">
                 <a:solidFill>
                   <a:srgbClr val="207354"/>
@@ -5637,6 +5737,7 @@
           </a:lstStyle>
           <a:p xmlns:a="http://schemas.openxmlformats.org/drawingml/2006/main">
             <a:pPr algn="l">
+              <a:buNone/>
               <a:defRPr sz="2250" b="1">
                 <a:solidFill>
                   <a:srgbClr val="207354"/>
@@ -5704,6 +5805,7 @@
               </a:defRPr>
             </a:defPPr>
             <a:lvl1pPr algn="l">
+              <a:buNone/>
               <a:defRPr sz="1800" b="0">
                 <a:solidFill>
                   <a:srgbClr val="17211C"/>
@@ -5714,6 +5816,7 @@
               </a:defRPr>
             </a:lvl1pPr>
             <a:lvl2pPr algn="l">
+              <a:buNone/>
               <a:defRPr sz="1800" b="0">
                 <a:solidFill>
                   <a:srgbClr val="17211C"/>
@@ -5724,6 +5827,7 @@
               </a:defRPr>
             </a:lvl2pPr>
             <a:lvl3pPr algn="l">
+              <a:buNone/>
               <a:defRPr sz="1800" b="0">
                 <a:solidFill>
                   <a:srgbClr val="17211C"/>
@@ -5734,6 +5838,7 @@
               </a:defRPr>
             </a:lvl3pPr>
             <a:lvl4pPr algn="l">
+              <a:buNone/>
               <a:defRPr sz="1800" b="0">
                 <a:solidFill>
                   <a:srgbClr val="17211C"/>
@@ -5744,6 +5849,7 @@
               </a:defRPr>
             </a:lvl4pPr>
             <a:lvl5pPr algn="l">
+              <a:buNone/>
               <a:defRPr sz="1800" b="0">
                 <a:solidFill>
                   <a:srgbClr val="17211C"/>
@@ -5754,6 +5860,7 @@
               </a:defRPr>
             </a:lvl5pPr>
             <a:lvl6pPr algn="l">
+              <a:buNone/>
               <a:defRPr sz="1800" b="0">
                 <a:solidFill>
                   <a:srgbClr val="17211C"/>
@@ -5764,6 +5871,7 @@
               </a:defRPr>
             </a:lvl6pPr>
             <a:lvl7pPr algn="l">
+              <a:buNone/>
               <a:defRPr sz="1800" b="0">
                 <a:solidFill>
                   <a:srgbClr val="17211C"/>
@@ -5774,6 +5882,7 @@
               </a:defRPr>
             </a:lvl7pPr>
             <a:lvl8pPr algn="l">
+              <a:buNone/>
               <a:defRPr sz="1800" b="0">
                 <a:solidFill>
                   <a:srgbClr val="17211C"/>
@@ -5784,6 +5893,7 @@
               </a:defRPr>
             </a:lvl8pPr>
             <a:lvl9pPr algn="l">
+              <a:buNone/>
               <a:defRPr sz="1800" b="0">
                 <a:solidFill>
                   <a:srgbClr val="17211C"/>
@@ -5796,6 +5906,7 @@
           </a:lstStyle>
           <a:p xmlns:a="http://schemas.openxmlformats.org/drawingml/2006/main">
             <a:pPr algn="l">
+              <a:buNone/>
               <a:defRPr sz="1800" b="0">
                 <a:solidFill>
                   <a:srgbClr val="17211C"/>
@@ -5819,6 +5930,7 @@
           </a:p>
           <a:p xmlns:a="http://schemas.openxmlformats.org/drawingml/2006/main">
             <a:pPr algn="l">
+              <a:buNone/>
               <a:defRPr sz="1800" b="0">
                 <a:solidFill>
                   <a:srgbClr val="17211C"/>
@@ -5886,6 +5998,7 @@
               </a:defRPr>
             </a:defPPr>
             <a:lvl1pPr algn="l">
+              <a:buNone/>
               <a:defRPr sz="2250" b="1">
                 <a:solidFill>
                   <a:srgbClr val="207354"/>
@@ -5896,6 +6009,7 @@
               </a:defRPr>
             </a:lvl1pPr>
             <a:lvl2pPr algn="l">
+              <a:buNone/>
               <a:defRPr sz="2250" b="1">
                 <a:solidFill>
                   <a:srgbClr val="207354"/>
@@ -5906,6 +6020,7 @@
               </a:defRPr>
             </a:lvl2pPr>
             <a:lvl3pPr algn="l">
+              <a:buNone/>
               <a:defRPr sz="2250" b="1">
                 <a:solidFill>
                   <a:srgbClr val="207354"/>
@@ -5916,6 +6031,7 @@
               </a:defRPr>
             </a:lvl3pPr>
             <a:lvl4pPr algn="l">
+              <a:buNone/>
               <a:defRPr sz="2250" b="1">
                 <a:solidFill>
                   <a:srgbClr val="207354"/>
@@ -5926,6 +6042,7 @@
               </a:defRPr>
             </a:lvl4pPr>
             <a:lvl5pPr algn="l">
+              <a:buNone/>
               <a:defRPr sz="2250" b="1">
                 <a:solidFill>
                   <a:srgbClr val="207354"/>
@@ -5936,6 +6053,7 @@
               </a:defRPr>
             </a:lvl5pPr>
             <a:lvl6pPr algn="l">
+              <a:buNone/>
               <a:defRPr sz="2250" b="1">
                 <a:solidFill>
                   <a:srgbClr val="207354"/>
@@ -5946,6 +6064,7 @@
               </a:defRPr>
             </a:lvl6pPr>
             <a:lvl7pPr algn="l">
+              <a:buNone/>
               <a:defRPr sz="2250" b="1">
                 <a:solidFill>
                   <a:srgbClr val="207354"/>
@@ -5956,6 +6075,7 @@
               </a:defRPr>
             </a:lvl7pPr>
             <a:lvl8pPr algn="l">
+              <a:buNone/>
               <a:defRPr sz="2250" b="1">
                 <a:solidFill>
                   <a:srgbClr val="207354"/>
@@ -5966,6 +6086,7 @@
               </a:defRPr>
             </a:lvl8pPr>
             <a:lvl9pPr algn="l">
+              <a:buNone/>
               <a:defRPr sz="2250" b="1">
                 <a:solidFill>
                   <a:srgbClr val="207354"/>
@@ -5978,6 +6099,7 @@
           </a:lstStyle>
           <a:p xmlns:a="http://schemas.openxmlformats.org/drawingml/2006/main">
             <a:pPr algn="l">
+              <a:buNone/>
               <a:defRPr sz="2250" b="1">
                 <a:solidFill>
                   <a:srgbClr val="207354"/>
@@ -6045,6 +6167,7 @@
               </a:defRPr>
             </a:defPPr>
             <a:lvl1pPr algn="l">
+              <a:buNone/>
               <a:defRPr sz="1800" b="0">
                 <a:solidFill>
                   <a:srgbClr val="17211C"/>
@@ -6055,6 +6178,7 @@
               </a:defRPr>
             </a:lvl1pPr>
             <a:lvl2pPr algn="l">
+              <a:buNone/>
               <a:defRPr sz="1800" b="0">
                 <a:solidFill>
                   <a:srgbClr val="17211C"/>
@@ -6065,6 +6189,7 @@
               </a:defRPr>
             </a:lvl2pPr>
             <a:lvl3pPr algn="l">
+              <a:buNone/>
               <a:defRPr sz="1800" b="0">
                 <a:solidFill>
                   <a:srgbClr val="17211C"/>
@@ -6075,6 +6200,7 @@
               </a:defRPr>
             </a:lvl3pPr>
             <a:lvl4pPr algn="l">
+              <a:buNone/>
               <a:defRPr sz="1800" b="0">
                 <a:solidFill>
                   <a:srgbClr val="17211C"/>
@@ -6085,6 +6211,7 @@
               </a:defRPr>
             </a:lvl4pPr>
             <a:lvl5pPr algn="l">
+              <a:buNone/>
               <a:defRPr sz="1800" b="0">
                 <a:solidFill>
                   <a:srgbClr val="17211C"/>
@@ -6095,6 +6222,7 @@
               </a:defRPr>
             </a:lvl5pPr>
             <a:lvl6pPr algn="l">
+              <a:buNone/>
               <a:defRPr sz="1800" b="0">
                 <a:solidFill>
                   <a:srgbClr val="17211C"/>
@@ -6105,6 +6233,7 @@
               </a:defRPr>
             </a:lvl6pPr>
             <a:lvl7pPr algn="l">
+              <a:buNone/>
               <a:defRPr sz="1800" b="0">
                 <a:solidFill>
                   <a:srgbClr val="17211C"/>
@@ -6115,6 +6244,7 @@
               </a:defRPr>
             </a:lvl7pPr>
             <a:lvl8pPr algn="l">
+              <a:buNone/>
               <a:defRPr sz="1800" b="0">
                 <a:solidFill>
                   <a:srgbClr val="17211C"/>
@@ -6125,6 +6255,7 @@
               </a:defRPr>
             </a:lvl8pPr>
             <a:lvl9pPr algn="l">
+              <a:buNone/>
               <a:defRPr sz="1800" b="0">
                 <a:solidFill>
                   <a:srgbClr val="17211C"/>
@@ -6137,6 +6268,7 @@
           </a:lstStyle>
           <a:p xmlns:a="http://schemas.openxmlformats.org/drawingml/2006/main">
             <a:pPr algn="l">
+              <a:buNone/>
               <a:defRPr sz="1800" b="0">
                 <a:solidFill>
                   <a:srgbClr val="17211C"/>
@@ -6160,6 +6292,7 @@
           </a:p>
           <a:p xmlns:a="http://schemas.openxmlformats.org/drawingml/2006/main">
             <a:pPr algn="l">
+              <a:buNone/>
               <a:defRPr sz="1800" b="0">
                 <a:solidFill>
                   <a:srgbClr val="17211C"/>
@@ -6188,7 +6321,7 @@
           <p:cNvPr id="7" name="">
             <a:extLst xmlns:a="http://schemas.openxmlformats.org/drawingml/2006/main">
               <a:ext uri="{FF2B5EF4-FFF2-40B4-BE49-F238E27FC236}">
-                <a16:creationId xmlns:a16="http://schemas.microsoft.com/office/drawing/2014/main" id="{1513BC75-2561-49AA-82E6-8FDE6113169E}"/>
+                <a16:creationId xmlns:a16="http://schemas.microsoft.com/office/drawing/2014/main" id="{1C12B80B-8E0A-4A17-BEEB-F2C25F99BD27}"/>
               </a:ext>
             </a:extLst>
           </p:cNvPr>
@@ -6198,7 +6331,7 @@
           <p:nvPr/>
         </p:nvPicPr>
         <p:blipFill>
-          <a:blip xmlns:r="http://schemas.openxmlformats.org/officeDocument/2006/relationships" xmlns:a="http://schemas.openxmlformats.org/drawingml/2006/main" r:embed="R48dc41ca6ff04440"/>
+          <a:blip xmlns:r="http://schemas.openxmlformats.org/officeDocument/2006/relationships" xmlns:a="http://schemas.openxmlformats.org/drawingml/2006/main" r:embed="R4a250afe6032486e"/>
           <a:stretch xmlns:a="http://schemas.openxmlformats.org/drawingml/2006/main"/>
         </p:blipFill>
         <p:spPr>
@@ -6284,6 +6417,7 @@
               </a:defRPr>
             </a:defPPr>
             <a:lvl1pPr algn="l">
+              <a:buNone/>
               <a:defRPr sz="2850" b="1">
                 <a:solidFill>
                   <a:srgbClr val="E8F0EA"/>
@@ -6294,6 +6428,7 @@
               </a:defRPr>
             </a:lvl1pPr>
             <a:lvl2pPr algn="l">
+              <a:buNone/>
               <a:defRPr sz="2850" b="1">
                 <a:solidFill>
                   <a:srgbClr val="E8F0EA"/>
@@ -6304,6 +6439,7 @@
               </a:defRPr>
             </a:lvl2pPr>
             <a:lvl3pPr algn="l">
+              <a:buNone/>
               <a:defRPr sz="2850" b="1">
                 <a:solidFill>
                   <a:srgbClr val="E8F0EA"/>
@@ -6314,6 +6450,7 @@
               </a:defRPr>
             </a:lvl3pPr>
             <a:lvl4pPr algn="l">
+              <a:buNone/>
               <a:defRPr sz="2850" b="1">
                 <a:solidFill>
                   <a:srgbClr val="E8F0EA"/>
@@ -6324,6 +6461,7 @@
               </a:defRPr>
             </a:lvl4pPr>
             <a:lvl5pPr algn="l">
+              <a:buNone/>
               <a:defRPr sz="2850" b="1">
                 <a:solidFill>
                   <a:srgbClr val="E8F0EA"/>
@@ -6334,6 +6472,7 @@
               </a:defRPr>
             </a:lvl5pPr>
             <a:lvl6pPr algn="l">
+              <a:buNone/>
               <a:defRPr sz="2850" b="1">
                 <a:solidFill>
                   <a:srgbClr val="E8F0EA"/>
@@ -6344,6 +6483,7 @@
               </a:defRPr>
             </a:lvl6pPr>
             <a:lvl7pPr algn="l">
+              <a:buNone/>
               <a:defRPr sz="2850" b="1">
                 <a:solidFill>
                   <a:srgbClr val="E8F0EA"/>
@@ -6354,6 +6494,7 @@
               </a:defRPr>
             </a:lvl7pPr>
             <a:lvl8pPr algn="l">
+              <a:buNone/>
               <a:defRPr sz="2850" b="1">
                 <a:solidFill>
                   <a:srgbClr val="E8F0EA"/>
@@ -6364,6 +6505,7 @@
               </a:defRPr>
             </a:lvl8pPr>
             <a:lvl9pPr algn="l">
+              <a:buNone/>
               <a:defRPr sz="2850" b="1">
                 <a:solidFill>
                   <a:srgbClr val="E8F0EA"/>
@@ -6376,6 +6518,7 @@
           </a:lstStyle>
           <a:p xmlns:a="http://schemas.openxmlformats.org/drawingml/2006/main">
             <a:pPr algn="l">
+              <a:buNone/>
               <a:defRPr sz="2850" b="1">
                 <a:solidFill>
                   <a:srgbClr val="E8F0EA"/>
@@ -6443,6 +6586,7 @@
               </a:defRPr>
             </a:defPPr>
             <a:lvl1pPr algn="l">
+              <a:buNone/>
               <a:defRPr sz="1575" b="0">
                 <a:solidFill>
                   <a:srgbClr val="78DEB6"/>
@@ -6453,6 +6597,7 @@
               </a:defRPr>
             </a:lvl1pPr>
             <a:lvl2pPr algn="l">
+              <a:buNone/>
               <a:defRPr sz="1575" b="0">
                 <a:solidFill>
                   <a:srgbClr val="78DEB6"/>
@@ -6463,6 +6608,7 @@
               </a:defRPr>
             </a:lvl2pPr>
             <a:lvl3pPr algn="l">
+              <a:buNone/>
               <a:defRPr sz="1575" b="0">
                 <a:solidFill>
                   <a:srgbClr val="78DEB6"/>
@@ -6473,6 +6619,7 @@
               </a:defRPr>
             </a:lvl3pPr>
             <a:lvl4pPr algn="l">
+              <a:buNone/>
               <a:defRPr sz="1575" b="0">
                 <a:solidFill>
                   <a:srgbClr val="78DEB6"/>
@@ -6483,6 +6630,7 @@
               </a:defRPr>
             </a:lvl4pPr>
             <a:lvl5pPr algn="l">
+              <a:buNone/>
               <a:defRPr sz="1575" b="0">
                 <a:solidFill>
                   <a:srgbClr val="78DEB6"/>
@@ -6493,6 +6641,7 @@
               </a:defRPr>
             </a:lvl5pPr>
             <a:lvl6pPr algn="l">
+              <a:buNone/>
               <a:defRPr sz="1575" b="0">
                 <a:solidFill>
                   <a:srgbClr val="78DEB6"/>
@@ -6503,6 +6652,7 @@
               </a:defRPr>
             </a:lvl6pPr>
             <a:lvl7pPr algn="l">
+              <a:buNone/>
               <a:defRPr sz="1575" b="0">
                 <a:solidFill>
                   <a:srgbClr val="78DEB6"/>
@@ -6513,6 +6663,7 @@
               </a:defRPr>
             </a:lvl7pPr>
             <a:lvl8pPr algn="l">
+              <a:buNone/>
               <a:defRPr sz="1575" b="0">
                 <a:solidFill>
                   <a:srgbClr val="78DEB6"/>
@@ -6523,6 +6674,7 @@
               </a:defRPr>
             </a:lvl8pPr>
             <a:lvl9pPr algn="l">
+              <a:buNone/>
               <a:defRPr sz="1575" b="0">
                 <a:solidFill>
                   <a:srgbClr val="78DEB6"/>
@@ -6535,6 +6687,7 @@
           </a:lstStyle>
           <a:p xmlns:a="http://schemas.openxmlformats.org/drawingml/2006/main">
             <a:pPr algn="l">
+              <a:buNone/>
               <a:defRPr sz="1575" b="0">
                 <a:solidFill>
                   <a:srgbClr val="78DEB6"/>
@@ -6602,6 +6755,7 @@
               </a:defRPr>
             </a:defPPr>
             <a:lvl1pPr algn="l">
+              <a:buNone/>
               <a:defRPr sz="3150" b="1">
                 <a:solidFill>
                   <a:srgbClr val="78DEB6"/>
@@ -6612,6 +6766,7 @@
               </a:defRPr>
             </a:lvl1pPr>
             <a:lvl2pPr algn="l">
+              <a:buNone/>
               <a:defRPr sz="3150" b="1">
                 <a:solidFill>
                   <a:srgbClr val="78DEB6"/>
@@ -6622,6 +6777,7 @@
               </a:defRPr>
             </a:lvl2pPr>
             <a:lvl3pPr algn="l">
+              <a:buNone/>
               <a:defRPr sz="3150" b="1">
                 <a:solidFill>
                   <a:srgbClr val="78DEB6"/>
@@ -6632,6 +6788,7 @@
               </a:defRPr>
             </a:lvl3pPr>
             <a:lvl4pPr algn="l">
+              <a:buNone/>
               <a:defRPr sz="3150" b="1">
                 <a:solidFill>
                   <a:srgbClr val="78DEB6"/>
@@ -6642,6 +6799,7 @@
               </a:defRPr>
             </a:lvl4pPr>
             <a:lvl5pPr algn="l">
+              <a:buNone/>
               <a:defRPr sz="3150" b="1">
                 <a:solidFill>
                   <a:srgbClr val="78DEB6"/>
@@ -6652,6 +6810,7 @@
               </a:defRPr>
             </a:lvl5pPr>
             <a:lvl6pPr algn="l">
+              <a:buNone/>
               <a:defRPr sz="3150" b="1">
                 <a:solidFill>
                   <a:srgbClr val="78DEB6"/>
@@ -6662,6 +6821,7 @@
               </a:defRPr>
             </a:lvl6pPr>
             <a:lvl7pPr algn="l">
+              <a:buNone/>
               <a:defRPr sz="3150" b="1">
                 <a:solidFill>
                   <a:srgbClr val="78DEB6"/>
@@ -6672,6 +6832,7 @@
               </a:defRPr>
             </a:lvl7pPr>
             <a:lvl8pPr algn="l">
+              <a:buNone/>
               <a:defRPr sz="3150" b="1">
                 <a:solidFill>
                   <a:srgbClr val="78DEB6"/>
@@ -6682,6 +6843,7 @@
               </a:defRPr>
             </a:lvl8pPr>
             <a:lvl9pPr algn="l">
+              <a:buNone/>
               <a:defRPr sz="3150" b="1">
                 <a:solidFill>
                   <a:srgbClr val="78DEB6"/>
@@ -6694,6 +6856,7 @@
           </a:lstStyle>
           <a:p xmlns:a="http://schemas.openxmlformats.org/drawingml/2006/main">
             <a:pPr algn="l">
+              <a:buNone/>
               <a:defRPr sz="3150" b="1">
                 <a:solidFill>
                   <a:srgbClr val="78DEB6"/>
@@ -6761,6 +6924,7 @@
               </a:defRPr>
             </a:defPPr>
             <a:lvl1pPr algn="l">
+              <a:buNone/>
               <a:defRPr sz="2175" b="0">
                 <a:solidFill>
                   <a:srgbClr val="E8F0EA"/>
@@ -6771,6 +6935,7 @@
               </a:defRPr>
             </a:lvl1pPr>
             <a:lvl2pPr algn="l">
+              <a:buNone/>
               <a:defRPr sz="2175" b="0">
                 <a:solidFill>
                   <a:srgbClr val="E8F0EA"/>
@@ -6781,6 +6946,7 @@
               </a:defRPr>
             </a:lvl2pPr>
             <a:lvl3pPr algn="l">
+              <a:buNone/>
               <a:defRPr sz="2175" b="0">
                 <a:solidFill>
                   <a:srgbClr val="E8F0EA"/>
@@ -6791,6 +6957,7 @@
               </a:defRPr>
             </a:lvl3pPr>
             <a:lvl4pPr algn="l">
+              <a:buNone/>
               <a:defRPr sz="2175" b="0">
                 <a:solidFill>
                   <a:srgbClr val="E8F0EA"/>
@@ -6801,6 +6968,7 @@
               </a:defRPr>
             </a:lvl4pPr>
             <a:lvl5pPr algn="l">
+              <a:buNone/>
               <a:defRPr sz="2175" b="0">
                 <a:solidFill>
                   <a:srgbClr val="E8F0EA"/>
@@ -6811,6 +6979,7 @@
               </a:defRPr>
             </a:lvl5pPr>
             <a:lvl6pPr algn="l">
+              <a:buNone/>
               <a:defRPr sz="2175" b="0">
                 <a:solidFill>
                   <a:srgbClr val="E8F0EA"/>
@@ -6821,6 +6990,7 @@
               </a:defRPr>
             </a:lvl6pPr>
             <a:lvl7pPr algn="l">
+              <a:buNone/>
               <a:defRPr sz="2175" b="0">
                 <a:solidFill>
                   <a:srgbClr val="E8F0EA"/>
@@ -6831,6 +7001,7 @@
               </a:defRPr>
             </a:lvl7pPr>
             <a:lvl8pPr algn="l">
+              <a:buNone/>
               <a:defRPr sz="2175" b="0">
                 <a:solidFill>
                   <a:srgbClr val="E8F0EA"/>
@@ -6841,6 +7012,7 @@
               </a:defRPr>
             </a:lvl8pPr>
             <a:lvl9pPr algn="l">
+              <a:buNone/>
               <a:defRPr sz="2175" b="0">
                 <a:solidFill>
                   <a:srgbClr val="E8F0EA"/>
@@ -6853,6 +7025,7 @@
           </a:lstStyle>
           <a:p xmlns:a="http://schemas.openxmlformats.org/drawingml/2006/main">
             <a:pPr algn="l">
+              <a:buNone/>
               <a:defRPr sz="2175" b="0">
                 <a:solidFill>
                   <a:srgbClr val="E8F0EA"/>
@@ -6920,6 +7093,7 @@
               </a:defRPr>
             </a:defPPr>
             <a:lvl1pPr algn="l">
+              <a:buNone/>
               <a:defRPr sz="3150" b="1">
                 <a:solidFill>
                   <a:srgbClr val="78DEB6"/>
@@ -6930,6 +7104,7 @@
               </a:defRPr>
             </a:lvl1pPr>
             <a:lvl2pPr algn="l">
+              <a:buNone/>
               <a:defRPr sz="3150" b="1">
                 <a:solidFill>
                   <a:srgbClr val="78DEB6"/>
@@ -6940,6 +7115,7 @@
               </a:defRPr>
             </a:lvl2pPr>
             <a:lvl3pPr algn="l">
+              <a:buNone/>
               <a:defRPr sz="3150" b="1">
                 <a:solidFill>
                   <a:srgbClr val="78DEB6"/>
@@ -6950,6 +7126,7 @@
               </a:defRPr>
             </a:lvl3pPr>
             <a:lvl4pPr algn="l">
+              <a:buNone/>
               <a:defRPr sz="3150" b="1">
                 <a:solidFill>
                   <a:srgbClr val="78DEB6"/>
@@ -6960,6 +7137,7 @@
               </a:defRPr>
             </a:lvl4pPr>
             <a:lvl5pPr algn="l">
+              <a:buNone/>
               <a:defRPr sz="3150" b="1">
                 <a:solidFill>
                   <a:srgbClr val="78DEB6"/>
@@ -6970,6 +7148,7 @@
               </a:defRPr>
             </a:lvl5pPr>
             <a:lvl6pPr algn="l">
+              <a:buNone/>
               <a:defRPr sz="3150" b="1">
                 <a:solidFill>
                   <a:srgbClr val="78DEB6"/>
@@ -6980,6 +7159,7 @@
               </a:defRPr>
             </a:lvl6pPr>
             <a:lvl7pPr algn="l">
+              <a:buNone/>
               <a:defRPr sz="3150" b="1">
                 <a:solidFill>
                   <a:srgbClr val="78DEB6"/>
@@ -6990,6 +7170,7 @@
               </a:defRPr>
             </a:lvl7pPr>
             <a:lvl8pPr algn="l">
+              <a:buNone/>
               <a:defRPr sz="3150" b="1">
                 <a:solidFill>
                   <a:srgbClr val="78DEB6"/>
@@ -7000,6 +7181,7 @@
               </a:defRPr>
             </a:lvl8pPr>
             <a:lvl9pPr algn="l">
+              <a:buNone/>
               <a:defRPr sz="3150" b="1">
                 <a:solidFill>
                   <a:srgbClr val="78DEB6"/>
@@ -7012,6 +7194,7 @@
           </a:lstStyle>
           <a:p xmlns:a="http://schemas.openxmlformats.org/drawingml/2006/main">
             <a:pPr algn="l">
+              <a:buNone/>
               <a:defRPr sz="3150" b="1">
                 <a:solidFill>
                   <a:srgbClr val="78DEB6"/>
@@ -7079,6 +7262,7 @@
               </a:defRPr>
             </a:defPPr>
             <a:lvl1pPr algn="l">
+              <a:buNone/>
               <a:defRPr sz="2175" b="0">
                 <a:solidFill>
                   <a:srgbClr val="E8F0EA"/>
@@ -7089,6 +7273,7 @@
               </a:defRPr>
             </a:lvl1pPr>
             <a:lvl2pPr algn="l">
+              <a:buNone/>
               <a:defRPr sz="2175" b="0">
                 <a:solidFill>
                   <a:srgbClr val="E8F0EA"/>
@@ -7099,6 +7284,7 @@
               </a:defRPr>
             </a:lvl2pPr>
             <a:lvl3pPr algn="l">
+              <a:buNone/>
               <a:defRPr sz="2175" b="0">
                 <a:solidFill>
                   <a:srgbClr val="E8F0EA"/>
@@ -7109,6 +7295,7 @@
               </a:defRPr>
             </a:lvl3pPr>
             <a:lvl4pPr algn="l">
+              <a:buNone/>
               <a:defRPr sz="2175" b="0">
                 <a:solidFill>
                   <a:srgbClr val="E8F0EA"/>
@@ -7119,6 +7306,7 @@
               </a:defRPr>
             </a:lvl4pPr>
             <a:lvl5pPr algn="l">
+              <a:buNone/>
               <a:defRPr sz="2175" b="0">
                 <a:solidFill>
                   <a:srgbClr val="E8F0EA"/>
@@ -7129,6 +7317,7 @@
               </a:defRPr>
             </a:lvl5pPr>
             <a:lvl6pPr algn="l">
+              <a:buNone/>
               <a:defRPr sz="2175" b="0">
                 <a:solidFill>
                   <a:srgbClr val="E8F0EA"/>
@@ -7139,6 +7328,7 @@
               </a:defRPr>
             </a:lvl6pPr>
             <a:lvl7pPr algn="l">
+              <a:buNone/>
               <a:defRPr sz="2175" b="0">
                 <a:solidFill>
                   <a:srgbClr val="E8F0EA"/>
@@ -7149,6 +7339,7 @@
               </a:defRPr>
             </a:lvl7pPr>
             <a:lvl8pPr algn="l">
+              <a:buNone/>
               <a:defRPr sz="2175" b="0">
                 <a:solidFill>
                   <a:srgbClr val="E8F0EA"/>
@@ -7159,6 +7350,7 @@
               </a:defRPr>
             </a:lvl8pPr>
             <a:lvl9pPr algn="l">
+              <a:buNone/>
               <a:defRPr sz="2175" b="0">
                 <a:solidFill>
                   <a:srgbClr val="E8F0EA"/>
@@ -7171,6 +7363,7 @@
           </a:lstStyle>
           <a:p xmlns:a="http://schemas.openxmlformats.org/drawingml/2006/main">
             <a:pPr algn="l">
+              <a:buNone/>
               <a:defRPr sz="2175" b="0">
                 <a:solidFill>
                   <a:srgbClr val="E8F0EA"/>
@@ -7238,6 +7431,7 @@
               </a:defRPr>
             </a:defPPr>
             <a:lvl1pPr algn="l">
+              <a:buNone/>
               <a:defRPr sz="3150" b="1">
                 <a:solidFill>
                   <a:srgbClr val="78DEB6"/>
@@ -7248,6 +7442,7 @@
               </a:defRPr>
             </a:lvl1pPr>
             <a:lvl2pPr algn="l">
+              <a:buNone/>
               <a:defRPr sz="3150" b="1">
                 <a:solidFill>
                   <a:srgbClr val="78DEB6"/>
@@ -7258,6 +7453,7 @@
               </a:defRPr>
             </a:lvl2pPr>
             <a:lvl3pPr algn="l">
+              <a:buNone/>
               <a:defRPr sz="3150" b="1">
                 <a:solidFill>
                   <a:srgbClr val="78DEB6"/>
@@ -7268,6 +7464,7 @@
               </a:defRPr>
             </a:lvl3pPr>
             <a:lvl4pPr algn="l">
+              <a:buNone/>
               <a:defRPr sz="3150" b="1">
                 <a:solidFill>
                   <a:srgbClr val="78DEB6"/>
@@ -7278,6 +7475,7 @@
               </a:defRPr>
             </a:lvl4pPr>
             <a:lvl5pPr algn="l">
+              <a:buNone/>
               <a:defRPr sz="3150" b="1">
                 <a:solidFill>
                   <a:srgbClr val="78DEB6"/>
@@ -7288,6 +7486,7 @@
               </a:defRPr>
             </a:lvl5pPr>
             <a:lvl6pPr algn="l">
+              <a:buNone/>
               <a:defRPr sz="3150" b="1">
                 <a:solidFill>
                   <a:srgbClr val="78DEB6"/>
@@ -7298,6 +7497,7 @@
               </a:defRPr>
             </a:lvl6pPr>
             <a:lvl7pPr algn="l">
+              <a:buNone/>
               <a:defRPr sz="3150" b="1">
                 <a:solidFill>
                   <a:srgbClr val="78DEB6"/>
@@ -7308,6 +7508,7 @@
               </a:defRPr>
             </a:lvl7pPr>
             <a:lvl8pPr algn="l">
+              <a:buNone/>
               <a:defRPr sz="3150" b="1">
                 <a:solidFill>
                   <a:srgbClr val="78DEB6"/>
@@ -7318,6 +7519,7 @@
               </a:defRPr>
             </a:lvl8pPr>
             <a:lvl9pPr algn="l">
+              <a:buNone/>
               <a:defRPr sz="3150" b="1">
                 <a:solidFill>
                   <a:srgbClr val="78DEB6"/>
@@ -7330,6 +7532,7 @@
           </a:lstStyle>
           <a:p xmlns:a="http://schemas.openxmlformats.org/drawingml/2006/main">
             <a:pPr algn="l">
+              <a:buNone/>
               <a:defRPr sz="3150" b="1">
                 <a:solidFill>
                   <a:srgbClr val="78DEB6"/>
@@ -7397,6 +7600,7 @@
               </a:defRPr>
             </a:defPPr>
             <a:lvl1pPr algn="l">
+              <a:buNone/>
               <a:defRPr sz="2175" b="0">
                 <a:solidFill>
                   <a:srgbClr val="E8F0EA"/>
@@ -7407,6 +7611,7 @@
               </a:defRPr>
             </a:lvl1pPr>
             <a:lvl2pPr algn="l">
+              <a:buNone/>
               <a:defRPr sz="2175" b="0">
                 <a:solidFill>
                   <a:srgbClr val="E8F0EA"/>
@@ -7417,6 +7622,7 @@
               </a:defRPr>
             </a:lvl2pPr>
             <a:lvl3pPr algn="l">
+              <a:buNone/>
               <a:defRPr sz="2175" b="0">
                 <a:solidFill>
                   <a:srgbClr val="E8F0EA"/>
@@ -7427,6 +7633,7 @@
               </a:defRPr>
             </a:lvl3pPr>
             <a:lvl4pPr algn="l">
+              <a:buNone/>
               <a:defRPr sz="2175" b="0">
                 <a:solidFill>
                   <a:srgbClr val="E8F0EA"/>
@@ -7437,6 +7644,7 @@
               </a:defRPr>
             </a:lvl4pPr>
             <a:lvl5pPr algn="l">
+              <a:buNone/>
               <a:defRPr sz="2175" b="0">
                 <a:solidFill>
                   <a:srgbClr val="E8F0EA"/>
@@ -7447,6 +7655,7 @@
               </a:defRPr>
             </a:lvl5pPr>
             <a:lvl6pPr algn="l">
+              <a:buNone/>
               <a:defRPr sz="2175" b="0">
                 <a:solidFill>
                   <a:srgbClr val="E8F0EA"/>
@@ -7457,6 +7666,7 @@
               </a:defRPr>
             </a:lvl6pPr>
             <a:lvl7pPr algn="l">
+              <a:buNone/>
               <a:defRPr sz="2175" b="0">
                 <a:solidFill>
                   <a:srgbClr val="E8F0EA"/>
@@ -7467,6 +7677,7 @@
               </a:defRPr>
             </a:lvl7pPr>
             <a:lvl8pPr algn="l">
+              <a:buNone/>
               <a:defRPr sz="2175" b="0">
                 <a:solidFill>
                   <a:srgbClr val="E8F0EA"/>
@@ -7477,6 +7688,7 @@
               </a:defRPr>
             </a:lvl8pPr>
             <a:lvl9pPr algn="l">
+              <a:buNone/>
               <a:defRPr sz="2175" b="0">
                 <a:solidFill>
                   <a:srgbClr val="E8F0EA"/>
@@ -7489,6 +7701,7 @@
           </a:lstStyle>
           <a:p xmlns:a="http://schemas.openxmlformats.org/drawingml/2006/main">
             <a:pPr algn="l">
+              <a:buNone/>
               <a:defRPr sz="2175" b="0">
                 <a:solidFill>
                   <a:srgbClr val="E8F0EA"/>
@@ -7556,6 +7769,7 @@
               </a:defRPr>
             </a:defPPr>
             <a:lvl1pPr algn="l">
+              <a:buNone/>
               <a:defRPr sz="3150" b="1">
                 <a:solidFill>
                   <a:srgbClr val="78DEB6"/>
@@ -7566,6 +7780,7 @@
               </a:defRPr>
             </a:lvl1pPr>
             <a:lvl2pPr algn="l">
+              <a:buNone/>
               <a:defRPr sz="3150" b="1">
                 <a:solidFill>
                   <a:srgbClr val="78DEB6"/>
@@ -7576,6 +7791,7 @@
               </a:defRPr>
             </a:lvl2pPr>
             <a:lvl3pPr algn="l">
+              <a:buNone/>
               <a:defRPr sz="3150" b="1">
                 <a:solidFill>
                   <a:srgbClr val="78DEB6"/>
@@ -7586,6 +7802,7 @@
               </a:defRPr>
             </a:lvl3pPr>
             <a:lvl4pPr algn="l">
+              <a:buNone/>
               <a:defRPr sz="3150" b="1">
                 <a:solidFill>
                   <a:srgbClr val="78DEB6"/>
@@ -7596,6 +7813,7 @@
               </a:defRPr>
             </a:lvl4pPr>
             <a:lvl5pPr algn="l">
+              <a:buNone/>
               <a:defRPr sz="3150" b="1">
                 <a:solidFill>
                   <a:srgbClr val="78DEB6"/>
@@ -7606,6 +7824,7 @@
               </a:defRPr>
             </a:lvl5pPr>
             <a:lvl6pPr algn="l">
+              <a:buNone/>
               <a:defRPr sz="3150" b="1">
                 <a:solidFill>
                   <a:srgbClr val="78DEB6"/>
@@ -7616,6 +7835,7 @@
               </a:defRPr>
             </a:lvl6pPr>
             <a:lvl7pPr algn="l">
+              <a:buNone/>
               <a:defRPr sz="3150" b="1">
                 <a:solidFill>
                   <a:srgbClr val="78DEB6"/>
@@ -7626,6 +7846,7 @@
               </a:defRPr>
             </a:lvl7pPr>
             <a:lvl8pPr algn="l">
+              <a:buNone/>
               <a:defRPr sz="3150" b="1">
                 <a:solidFill>
                   <a:srgbClr val="78DEB6"/>
@@ -7636,6 +7857,7 @@
               </a:defRPr>
             </a:lvl8pPr>
             <a:lvl9pPr algn="l">
+              <a:buNone/>
               <a:defRPr sz="3150" b="1">
                 <a:solidFill>
                   <a:srgbClr val="78DEB6"/>
@@ -7648,6 +7870,7 @@
           </a:lstStyle>
           <a:p xmlns:a="http://schemas.openxmlformats.org/drawingml/2006/main">
             <a:pPr algn="l">
+              <a:buNone/>
               <a:defRPr sz="3150" b="1">
                 <a:solidFill>
                   <a:srgbClr val="78DEB6"/>
@@ -7715,6 +7938,7 @@
               </a:defRPr>
             </a:defPPr>
             <a:lvl1pPr algn="l">
+              <a:buNone/>
               <a:defRPr sz="2175" b="0">
                 <a:solidFill>
                   <a:srgbClr val="E8F0EA"/>
@@ -7725,6 +7949,7 @@
               </a:defRPr>
             </a:lvl1pPr>
             <a:lvl2pPr algn="l">
+              <a:buNone/>
               <a:defRPr sz="2175" b="0">
                 <a:solidFill>
                   <a:srgbClr val="E8F0EA"/>
@@ -7735,6 +7960,7 @@
               </a:defRPr>
             </a:lvl2pPr>
             <a:lvl3pPr algn="l">
+              <a:buNone/>
               <a:defRPr sz="2175" b="0">
                 <a:solidFill>
                   <a:srgbClr val="E8F0EA"/>
@@ -7745,6 +7971,7 @@
               </a:defRPr>
             </a:lvl3pPr>
             <a:lvl4pPr algn="l">
+              <a:buNone/>
               <a:defRPr sz="2175" b="0">
                 <a:solidFill>
                   <a:srgbClr val="E8F0EA"/>
@@ -7755,6 +7982,7 @@
               </a:defRPr>
             </a:lvl4pPr>
             <a:lvl5pPr algn="l">
+              <a:buNone/>
               <a:defRPr sz="2175" b="0">
                 <a:solidFill>
                   <a:srgbClr val="E8F0EA"/>
@@ -7765,6 +7993,7 @@
               </a:defRPr>
             </a:lvl5pPr>
             <a:lvl6pPr algn="l">
+              <a:buNone/>
               <a:defRPr sz="2175" b="0">
                 <a:solidFill>
                   <a:srgbClr val="E8F0EA"/>
@@ -7775,6 +8004,7 @@
               </a:defRPr>
             </a:lvl6pPr>
             <a:lvl7pPr algn="l">
+              <a:buNone/>
               <a:defRPr sz="2175" b="0">
                 <a:solidFill>
                   <a:srgbClr val="E8F0EA"/>
@@ -7785,6 +8015,7 @@
               </a:defRPr>
             </a:lvl7pPr>
             <a:lvl8pPr algn="l">
+              <a:buNone/>
               <a:defRPr sz="2175" b="0">
                 <a:solidFill>
                   <a:srgbClr val="E8F0EA"/>
@@ -7795,6 +8026,7 @@
               </a:defRPr>
             </a:lvl8pPr>
             <a:lvl9pPr algn="l">
+              <a:buNone/>
               <a:defRPr sz="2175" b="0">
                 <a:solidFill>
                   <a:srgbClr val="E8F0EA"/>
@@ -7807,6 +8039,7 @@
           </a:lstStyle>
           <a:p xmlns:a="http://schemas.openxmlformats.org/drawingml/2006/main">
             <a:pPr algn="l">
+              <a:buNone/>
               <a:defRPr sz="2175" b="0">
                 <a:solidFill>
                   <a:srgbClr val="E8F0EA"/>
@@ -7826,6 +8059,165 @@
                 <a:cs typeface="Apple SD Gothic Neo"/>
               </a:rPr>
               <a:t>카드 응답 뒤 다른 상황의 문제로 다시 확인한다</a:t>
+            </a:r>
+          </a:p>
+        </p:txBody>
+      </p:sp>
+      <p:sp>
+        <p:nvSpPr>
+          <p:cNvPr id="12" name="current-generation-scope">
+            <a:extLst xmlns:a="http://schemas.openxmlformats.org/drawingml/2006/main">
+              <a:ext uri="{FF2B5EF4-FFF2-40B4-BE49-F238E27FC236}">
+                <a16:creationId xmlns:a16="http://schemas.microsoft.com/office/drawing/2014/main" id="{8734089A-AE81-41C3-8B94-F19057E80156}"/>
+              </a:ext>
+            </a:extLst>
+          </p:cNvPr>
+          <p:cNvSpPr>
+            <a:spLocks xmlns:a="http://schemas.openxmlformats.org/drawingml/2006/main" noGrp="1"/>
+          </p:cNvSpPr>
+          <p:nvPr/>
+        </p:nvSpPr>
+        <p:spPr>
+          <a:xfrm xmlns:a="http://schemas.openxmlformats.org/drawingml/2006/main">
+            <a:off x="723900" y="5762625"/>
+            <a:ext cx="10744200" cy="514350"/>
+          </a:xfrm>
+          <a:prstGeom xmlns:a="http://schemas.openxmlformats.org/drawingml/2006/main" prst="rect">
+            <a:avLst/>
+          </a:prstGeom>
+          <a:noFill xmlns:a="http://schemas.openxmlformats.org/drawingml/2006/main"/>
+          <a:ln xmlns:a="http://schemas.openxmlformats.org/drawingml/2006/main" w="0">
+            <a:noFill/>
+            <a:prstDash val="solid"/>
+          </a:ln>
+        </p:spPr>
+        <p:txBody>
+          <a:bodyPr xmlns:a="http://schemas.openxmlformats.org/drawingml/2006/main" wrap="square" lIns="0" tIns="0" rIns="0" bIns="0" anchor="ctr">
+            <a:normAutofit fontScale="100000"/>
+          </a:bodyPr>
+          <a:lstStyle xmlns:a="http://schemas.openxmlformats.org/drawingml/2006/main">
+            <a:defPPr algn="l">
+              <a:defRPr sz="1725">
+                <a:solidFill>
+                  <a:srgbClr val="78DEB6"/>
+                </a:solidFill>
+                <a:latin typeface="Apple SD Gothic Neo"/>
+                <a:ea typeface="Apple SD Gothic Neo"/>
+                <a:cs typeface="Apple SD Gothic Neo"/>
+              </a:defRPr>
+            </a:defPPr>
+            <a:lvl1pPr algn="l">
+              <a:defRPr sz="1725">
+                <a:solidFill>
+                  <a:srgbClr val="78DEB6"/>
+                </a:solidFill>
+                <a:latin typeface="Apple SD Gothic Neo"/>
+                <a:ea typeface="Apple SD Gothic Neo"/>
+                <a:cs typeface="Apple SD Gothic Neo"/>
+              </a:defRPr>
+            </a:lvl1pPr>
+            <a:lvl2pPr algn="l">
+              <a:defRPr sz="1725">
+                <a:solidFill>
+                  <a:srgbClr val="78DEB6"/>
+                </a:solidFill>
+                <a:latin typeface="Apple SD Gothic Neo"/>
+                <a:ea typeface="Apple SD Gothic Neo"/>
+                <a:cs typeface="Apple SD Gothic Neo"/>
+              </a:defRPr>
+            </a:lvl2pPr>
+            <a:lvl3pPr algn="l">
+              <a:defRPr sz="1725">
+                <a:solidFill>
+                  <a:srgbClr val="78DEB6"/>
+                </a:solidFill>
+                <a:latin typeface="Apple SD Gothic Neo"/>
+                <a:ea typeface="Apple SD Gothic Neo"/>
+                <a:cs typeface="Apple SD Gothic Neo"/>
+              </a:defRPr>
+            </a:lvl3pPr>
+            <a:lvl4pPr algn="l">
+              <a:defRPr sz="1725">
+                <a:solidFill>
+                  <a:srgbClr val="78DEB6"/>
+                </a:solidFill>
+                <a:latin typeface="Apple SD Gothic Neo"/>
+                <a:ea typeface="Apple SD Gothic Neo"/>
+                <a:cs typeface="Apple SD Gothic Neo"/>
+              </a:defRPr>
+            </a:lvl4pPr>
+            <a:lvl5pPr algn="l">
+              <a:defRPr sz="1725">
+                <a:solidFill>
+                  <a:srgbClr val="78DEB6"/>
+                </a:solidFill>
+                <a:latin typeface="Apple SD Gothic Neo"/>
+                <a:ea typeface="Apple SD Gothic Neo"/>
+                <a:cs typeface="Apple SD Gothic Neo"/>
+              </a:defRPr>
+            </a:lvl5pPr>
+            <a:lvl6pPr algn="l">
+              <a:defRPr sz="1725">
+                <a:solidFill>
+                  <a:srgbClr val="78DEB6"/>
+                </a:solidFill>
+                <a:latin typeface="Apple SD Gothic Neo"/>
+                <a:ea typeface="Apple SD Gothic Neo"/>
+                <a:cs typeface="Apple SD Gothic Neo"/>
+              </a:defRPr>
+            </a:lvl6pPr>
+            <a:lvl7pPr algn="l">
+              <a:defRPr sz="1725">
+                <a:solidFill>
+                  <a:srgbClr val="78DEB6"/>
+                </a:solidFill>
+                <a:latin typeface="Apple SD Gothic Neo"/>
+                <a:ea typeface="Apple SD Gothic Neo"/>
+                <a:cs typeface="Apple SD Gothic Neo"/>
+              </a:defRPr>
+            </a:lvl7pPr>
+            <a:lvl8pPr algn="l">
+              <a:defRPr sz="1725">
+                <a:solidFill>
+                  <a:srgbClr val="78DEB6"/>
+                </a:solidFill>
+                <a:latin typeface="Apple SD Gothic Neo"/>
+                <a:ea typeface="Apple SD Gothic Neo"/>
+                <a:cs typeface="Apple SD Gothic Neo"/>
+              </a:defRPr>
+            </a:lvl8pPr>
+            <a:lvl9pPr algn="l">
+              <a:defRPr sz="1725">
+                <a:solidFill>
+                  <a:srgbClr val="78DEB6"/>
+                </a:solidFill>
+                <a:latin typeface="Apple SD Gothic Neo"/>
+                <a:ea typeface="Apple SD Gothic Neo"/>
+                <a:cs typeface="Apple SD Gothic Neo"/>
+              </a:defRPr>
+            </a:lvl9pPr>
+          </a:lstStyle>
+          <a:p xmlns:a="http://schemas.openxmlformats.org/drawingml/2006/main">
+            <a:pPr algn="l">
+              <a:defRPr sz="1725">
+                <a:solidFill>
+                  <a:srgbClr val="78DEB6"/>
+                </a:solidFill>
+                <a:latin typeface="Apple SD Gothic Neo"/>
+                <a:ea typeface="Apple SD Gothic Neo"/>
+                <a:cs typeface="Apple SD Gothic Neo"/>
+              </a:defRPr>
+            </a:pPr>
+            <a:r>
+              <a:rPr sz="1725">
+                <a:solidFill>
+                  <a:srgbClr val="78DEB6"/>
+                </a:solidFill>
+                <a:latin typeface="Apple SD Gothic Neo"/>
+                <a:ea typeface="Apple SD Gothic Neo"/>
+                <a:cs typeface="Apple SD Gothic Neo"/>
+              </a:rPr>
+              <a:t>현재: 스택·큐·기본키·외래키 4개념  ·  목표: 전체 학습 개념으로 확대</a:t>
             </a:r>
           </a:p>
         </p:txBody>
@@ -7903,6 +8295,7 @@
               </a:defRPr>
             </a:defPPr>
             <a:lvl1pPr algn="l">
+              <a:buNone/>
               <a:defRPr sz="2850" b="1">
                 <a:solidFill>
                   <a:srgbClr val="121513"/>
@@ -7913,6 +8306,7 @@
               </a:defRPr>
             </a:lvl1pPr>
             <a:lvl2pPr algn="l">
+              <a:buNone/>
               <a:defRPr sz="2850" b="1">
                 <a:solidFill>
                   <a:srgbClr val="121513"/>
@@ -7923,6 +8317,7 @@
               </a:defRPr>
             </a:lvl2pPr>
             <a:lvl3pPr algn="l">
+              <a:buNone/>
               <a:defRPr sz="2850" b="1">
                 <a:solidFill>
                   <a:srgbClr val="121513"/>
@@ -7933,6 +8328,7 @@
               </a:defRPr>
             </a:lvl3pPr>
             <a:lvl4pPr algn="l">
+              <a:buNone/>
               <a:defRPr sz="2850" b="1">
                 <a:solidFill>
                   <a:srgbClr val="121513"/>
@@ -7943,6 +8339,7 @@
               </a:defRPr>
             </a:lvl4pPr>
             <a:lvl5pPr algn="l">
+              <a:buNone/>
               <a:defRPr sz="2850" b="1">
                 <a:solidFill>
                   <a:srgbClr val="121513"/>
@@ -7953,6 +8350,7 @@
               </a:defRPr>
             </a:lvl5pPr>
             <a:lvl6pPr algn="l">
+              <a:buNone/>
               <a:defRPr sz="2850" b="1">
                 <a:solidFill>
                   <a:srgbClr val="121513"/>
@@ -7963,6 +8361,7 @@
               </a:defRPr>
             </a:lvl6pPr>
             <a:lvl7pPr algn="l">
+              <a:buNone/>
               <a:defRPr sz="2850" b="1">
                 <a:solidFill>
                   <a:srgbClr val="121513"/>
@@ -7973,6 +8372,7 @@
               </a:defRPr>
             </a:lvl7pPr>
             <a:lvl8pPr algn="l">
+              <a:buNone/>
               <a:defRPr sz="2850" b="1">
                 <a:solidFill>
                   <a:srgbClr val="121513"/>
@@ -7983,6 +8383,7 @@
               </a:defRPr>
             </a:lvl8pPr>
             <a:lvl9pPr algn="l">
+              <a:buNone/>
               <a:defRPr sz="2850" b="1">
                 <a:solidFill>
                   <a:srgbClr val="121513"/>
@@ -7995,6 +8396,7 @@
           </a:lstStyle>
           <a:p xmlns:a="http://schemas.openxmlformats.org/drawingml/2006/main">
             <a:pPr algn="l">
+              <a:buNone/>
               <a:defRPr sz="2850" b="1">
                 <a:solidFill>
                   <a:srgbClr val="121513"/>
@@ -8062,6 +8464,7 @@
               </a:defRPr>
             </a:defPPr>
             <a:lvl1pPr algn="l">
+              <a:buNone/>
               <a:defRPr sz="1575" b="0">
                 <a:solidFill>
                   <a:srgbClr val="207354"/>
@@ -8072,6 +8475,7 @@
               </a:defRPr>
             </a:lvl1pPr>
             <a:lvl2pPr algn="l">
+              <a:buNone/>
               <a:defRPr sz="1575" b="0">
                 <a:solidFill>
                   <a:srgbClr val="207354"/>
@@ -8082,6 +8486,7 @@
               </a:defRPr>
             </a:lvl2pPr>
             <a:lvl3pPr algn="l">
+              <a:buNone/>
               <a:defRPr sz="1575" b="0">
                 <a:solidFill>
                   <a:srgbClr val="207354"/>
@@ -8092,6 +8497,7 @@
               </a:defRPr>
             </a:lvl3pPr>
             <a:lvl4pPr algn="l">
+              <a:buNone/>
               <a:defRPr sz="1575" b="0">
                 <a:solidFill>
                   <a:srgbClr val="207354"/>
@@ -8102,6 +8508,7 @@
               </a:defRPr>
             </a:lvl4pPr>
             <a:lvl5pPr algn="l">
+              <a:buNone/>
               <a:defRPr sz="1575" b="0">
                 <a:solidFill>
                   <a:srgbClr val="207354"/>
@@ -8112,6 +8519,7 @@
               </a:defRPr>
             </a:lvl5pPr>
             <a:lvl6pPr algn="l">
+              <a:buNone/>
               <a:defRPr sz="1575" b="0">
                 <a:solidFill>
                   <a:srgbClr val="207354"/>
@@ -8122,6 +8530,7 @@
               </a:defRPr>
             </a:lvl6pPr>
             <a:lvl7pPr algn="l">
+              <a:buNone/>
               <a:defRPr sz="1575" b="0">
                 <a:solidFill>
                   <a:srgbClr val="207354"/>
@@ -8132,6 +8541,7 @@
               </a:defRPr>
             </a:lvl7pPr>
             <a:lvl8pPr algn="l">
+              <a:buNone/>
               <a:defRPr sz="1575" b="0">
                 <a:solidFill>
                   <a:srgbClr val="207354"/>
@@ -8142,6 +8552,7 @@
               </a:defRPr>
             </a:lvl8pPr>
             <a:lvl9pPr algn="l">
+              <a:buNone/>
               <a:defRPr sz="1575" b="0">
                 <a:solidFill>
                   <a:srgbClr val="207354"/>
@@ -8154,6 +8565,7 @@
           </a:lstStyle>
           <a:p xmlns:a="http://schemas.openxmlformats.org/drawingml/2006/main">
             <a:pPr algn="l">
+              <a:buNone/>
               <a:defRPr sz="1575" b="0">
                 <a:solidFill>
                   <a:srgbClr val="207354"/>
@@ -8221,6 +8633,7 @@
               </a:defRPr>
             </a:defPPr>
             <a:lvl1pPr algn="l">
+              <a:buNone/>
               <a:defRPr sz="2775" b="1">
                 <a:solidFill>
                   <a:srgbClr val="207354"/>
@@ -8231,6 +8644,7 @@
               </a:defRPr>
             </a:lvl1pPr>
             <a:lvl2pPr algn="l">
+              <a:buNone/>
               <a:defRPr sz="2775" b="1">
                 <a:solidFill>
                   <a:srgbClr val="207354"/>
@@ -8241,6 +8655,7 @@
               </a:defRPr>
             </a:lvl2pPr>
             <a:lvl3pPr algn="l">
+              <a:buNone/>
               <a:defRPr sz="2775" b="1">
                 <a:solidFill>
                   <a:srgbClr val="207354"/>
@@ -8251,6 +8666,7 @@
               </a:defRPr>
             </a:lvl3pPr>
             <a:lvl4pPr algn="l">
+              <a:buNone/>
               <a:defRPr sz="2775" b="1">
                 <a:solidFill>
                   <a:srgbClr val="207354"/>
@@ -8261,6 +8677,7 @@
               </a:defRPr>
             </a:lvl4pPr>
             <a:lvl5pPr algn="l">
+              <a:buNone/>
               <a:defRPr sz="2775" b="1">
                 <a:solidFill>
                   <a:srgbClr val="207354"/>
@@ -8271,6 +8688,7 @@
               </a:defRPr>
             </a:lvl5pPr>
             <a:lvl6pPr algn="l">
+              <a:buNone/>
               <a:defRPr sz="2775" b="1">
                 <a:solidFill>
                   <a:srgbClr val="207354"/>
@@ -8281,6 +8699,7 @@
               </a:defRPr>
             </a:lvl6pPr>
             <a:lvl7pPr algn="l">
+              <a:buNone/>
               <a:defRPr sz="2775" b="1">
                 <a:solidFill>
                   <a:srgbClr val="207354"/>
@@ -8291,6 +8710,7 @@
               </a:defRPr>
             </a:lvl7pPr>
             <a:lvl8pPr algn="l">
+              <a:buNone/>
               <a:defRPr sz="2775" b="1">
                 <a:solidFill>
                   <a:srgbClr val="207354"/>
@@ -8301,6 +8721,7 @@
               </a:defRPr>
             </a:lvl8pPr>
             <a:lvl9pPr algn="l">
+              <a:buNone/>
               <a:defRPr sz="2775" b="1">
                 <a:solidFill>
                   <a:srgbClr val="207354"/>
@@ -8313,6 +8734,7 @@
           </a:lstStyle>
           <a:p xmlns:a="http://schemas.openxmlformats.org/drawingml/2006/main">
             <a:pPr algn="l">
+              <a:buNone/>
               <a:defRPr sz="2775" b="1">
                 <a:solidFill>
                   <a:srgbClr val="207354"/>
@@ -8380,6 +8802,7 @@
               </a:defRPr>
             </a:defPPr>
             <a:lvl1pPr algn="l">
+              <a:buNone/>
               <a:defRPr sz="1875" b="0">
                 <a:solidFill>
                   <a:srgbClr val="17211C"/>
@@ -8390,6 +8813,7 @@
               </a:defRPr>
             </a:lvl1pPr>
             <a:lvl2pPr algn="l">
+              <a:buNone/>
               <a:defRPr sz="1875" b="0">
                 <a:solidFill>
                   <a:srgbClr val="17211C"/>
@@ -8400,6 +8824,7 @@
               </a:defRPr>
             </a:lvl2pPr>
             <a:lvl3pPr algn="l">
+              <a:buNone/>
               <a:defRPr sz="1875" b="0">
                 <a:solidFill>
                   <a:srgbClr val="17211C"/>
@@ -8410,6 +8835,7 @@
               </a:defRPr>
             </a:lvl3pPr>
             <a:lvl4pPr algn="l">
+              <a:buNone/>
               <a:defRPr sz="1875" b="0">
                 <a:solidFill>
                   <a:srgbClr val="17211C"/>
@@ -8420,6 +8846,7 @@
               </a:defRPr>
             </a:lvl4pPr>
             <a:lvl5pPr algn="l">
+              <a:buNone/>
               <a:defRPr sz="1875" b="0">
                 <a:solidFill>
                   <a:srgbClr val="17211C"/>
@@ -8430,6 +8857,7 @@
               </a:defRPr>
             </a:lvl5pPr>
             <a:lvl6pPr algn="l">
+              <a:buNone/>
               <a:defRPr sz="1875" b="0">
                 <a:solidFill>
                   <a:srgbClr val="17211C"/>
@@ -8440,6 +8868,7 @@
               </a:defRPr>
             </a:lvl6pPr>
             <a:lvl7pPr algn="l">
+              <a:buNone/>
               <a:defRPr sz="1875" b="0">
                 <a:solidFill>
                   <a:srgbClr val="17211C"/>
@@ -8450,6 +8879,7 @@
               </a:defRPr>
             </a:lvl7pPr>
             <a:lvl8pPr algn="l">
+              <a:buNone/>
               <a:defRPr sz="1875" b="0">
                 <a:solidFill>
                   <a:srgbClr val="17211C"/>
@@ -8460,6 +8890,7 @@
               </a:defRPr>
             </a:lvl8pPr>
             <a:lvl9pPr algn="l">
+              <a:buNone/>
               <a:defRPr sz="1875" b="0">
                 <a:solidFill>
                   <a:srgbClr val="17211C"/>
@@ -8472,6 +8903,7 @@
           </a:lstStyle>
           <a:p xmlns:a="http://schemas.openxmlformats.org/drawingml/2006/main">
             <a:pPr algn="l">
+              <a:buNone/>
               <a:defRPr sz="1875" b="0">
                 <a:solidFill>
                   <a:srgbClr val="17211C"/>
@@ -8495,6 +8927,7 @@
           </a:p>
           <a:p xmlns:a="http://schemas.openxmlformats.org/drawingml/2006/main">
             <a:pPr algn="l">
+              <a:buNone/>
               <a:defRPr sz="1875" b="0">
                 <a:solidFill>
                   <a:srgbClr val="17211C"/>
@@ -8518,6 +8951,7 @@
           </a:p>
           <a:p xmlns:a="http://schemas.openxmlformats.org/drawingml/2006/main">
             <a:pPr algn="l">
+              <a:buNone/>
               <a:defRPr sz="1875" b="0">
                 <a:solidFill>
                   <a:srgbClr val="17211C"/>
@@ -8585,6 +9019,7 @@
               </a:defRPr>
             </a:defPPr>
             <a:lvl1pPr algn="l">
+              <a:buNone/>
               <a:defRPr sz="2775" b="1">
                 <a:solidFill>
                   <a:srgbClr val="207354"/>
@@ -8595,6 +9030,7 @@
               </a:defRPr>
             </a:lvl1pPr>
             <a:lvl2pPr algn="l">
+              <a:buNone/>
               <a:defRPr sz="2775" b="1">
                 <a:solidFill>
                   <a:srgbClr val="207354"/>
@@ -8605,6 +9041,7 @@
               </a:defRPr>
             </a:lvl2pPr>
             <a:lvl3pPr algn="l">
+              <a:buNone/>
               <a:defRPr sz="2775" b="1">
                 <a:solidFill>
                   <a:srgbClr val="207354"/>
@@ -8615,6 +9052,7 @@
               </a:defRPr>
             </a:lvl3pPr>
             <a:lvl4pPr algn="l">
+              <a:buNone/>
               <a:defRPr sz="2775" b="1">
                 <a:solidFill>
                   <a:srgbClr val="207354"/>
@@ -8625,6 +9063,7 @@
               </a:defRPr>
             </a:lvl4pPr>
             <a:lvl5pPr algn="l">
+              <a:buNone/>
               <a:defRPr sz="2775" b="1">
                 <a:solidFill>
                   <a:srgbClr val="207354"/>
@@ -8635,6 +9074,7 @@
               </a:defRPr>
             </a:lvl5pPr>
             <a:lvl6pPr algn="l">
+              <a:buNone/>
               <a:defRPr sz="2775" b="1">
                 <a:solidFill>
                   <a:srgbClr val="207354"/>
@@ -8645,6 +9085,7 @@
               </a:defRPr>
             </a:lvl6pPr>
             <a:lvl7pPr algn="l">
+              <a:buNone/>
               <a:defRPr sz="2775" b="1">
                 <a:solidFill>
                   <a:srgbClr val="207354"/>
@@ -8655,6 +9096,7 @@
               </a:defRPr>
             </a:lvl7pPr>
             <a:lvl8pPr algn="l">
+              <a:buNone/>
               <a:defRPr sz="2775" b="1">
                 <a:solidFill>
                   <a:srgbClr val="207354"/>
@@ -8665,6 +9107,7 @@
               </a:defRPr>
             </a:lvl8pPr>
             <a:lvl9pPr algn="l">
+              <a:buNone/>
               <a:defRPr sz="2775" b="1">
                 <a:solidFill>
                   <a:srgbClr val="207354"/>
@@ -8677,6 +9120,7 @@
           </a:lstStyle>
           <a:p xmlns:a="http://schemas.openxmlformats.org/drawingml/2006/main">
             <a:pPr algn="l">
+              <a:buNone/>
               <a:defRPr sz="2775" b="1">
                 <a:solidFill>
                   <a:srgbClr val="207354"/>
@@ -8744,6 +9188,7 @@
               </a:defRPr>
             </a:defPPr>
             <a:lvl1pPr algn="l">
+              <a:buNone/>
               <a:defRPr sz="1875" b="0">
                 <a:solidFill>
                   <a:srgbClr val="17211C"/>
@@ -8754,6 +9199,7 @@
               </a:defRPr>
             </a:lvl1pPr>
             <a:lvl2pPr algn="l">
+              <a:buNone/>
               <a:defRPr sz="1875" b="0">
                 <a:solidFill>
                   <a:srgbClr val="17211C"/>
@@ -8764,6 +9210,7 @@
               </a:defRPr>
             </a:lvl2pPr>
             <a:lvl3pPr algn="l">
+              <a:buNone/>
               <a:defRPr sz="1875" b="0">
                 <a:solidFill>
                   <a:srgbClr val="17211C"/>
@@ -8774,6 +9221,7 @@
               </a:defRPr>
             </a:lvl3pPr>
             <a:lvl4pPr algn="l">
+              <a:buNone/>
               <a:defRPr sz="1875" b="0">
                 <a:solidFill>
                   <a:srgbClr val="17211C"/>
@@ -8784,6 +9232,7 @@
               </a:defRPr>
             </a:lvl4pPr>
             <a:lvl5pPr algn="l">
+              <a:buNone/>
               <a:defRPr sz="1875" b="0">
                 <a:solidFill>
                   <a:srgbClr val="17211C"/>
@@ -8794,6 +9243,7 @@
               </a:defRPr>
             </a:lvl5pPr>
             <a:lvl6pPr algn="l">
+              <a:buNone/>
               <a:defRPr sz="1875" b="0">
                 <a:solidFill>
                   <a:srgbClr val="17211C"/>
@@ -8804,6 +9254,7 @@
               </a:defRPr>
             </a:lvl6pPr>
             <a:lvl7pPr algn="l">
+              <a:buNone/>
               <a:defRPr sz="1875" b="0">
                 <a:solidFill>
                   <a:srgbClr val="17211C"/>
@@ -8814,6 +9265,7 @@
               </a:defRPr>
             </a:lvl7pPr>
             <a:lvl8pPr algn="l">
+              <a:buNone/>
               <a:defRPr sz="1875" b="0">
                 <a:solidFill>
                   <a:srgbClr val="17211C"/>
@@ -8824,6 +9276,7 @@
               </a:defRPr>
             </a:lvl8pPr>
             <a:lvl9pPr algn="l">
+              <a:buNone/>
               <a:defRPr sz="1875" b="0">
                 <a:solidFill>
                   <a:srgbClr val="17211C"/>
@@ -8836,6 +9289,7 @@
           </a:lstStyle>
           <a:p xmlns:a="http://schemas.openxmlformats.org/drawingml/2006/main">
             <a:pPr algn="l">
+              <a:buNone/>
               <a:defRPr sz="1875" b="0">
                 <a:solidFill>
                   <a:srgbClr val="17211C"/>
@@ -8859,6 +9313,7 @@
           </a:p>
           <a:p xmlns:a="http://schemas.openxmlformats.org/drawingml/2006/main">
             <a:pPr algn="l">
+              <a:buNone/>
               <a:defRPr sz="1875" b="0">
                 <a:solidFill>
                   <a:srgbClr val="17211C"/>
@@ -8882,6 +9337,7 @@
           </a:p>
           <a:p xmlns:a="http://schemas.openxmlformats.org/drawingml/2006/main">
             <a:pPr algn="l">
+              <a:buNone/>
               <a:defRPr sz="1875" b="0">
                 <a:solidFill>
                   <a:srgbClr val="17211C"/>
@@ -8949,6 +9405,7 @@
               </a:defRPr>
             </a:defPPr>
             <a:lvl1pPr algn="l">
+              <a:buNone/>
               <a:defRPr sz="1650" b="0">
                 <a:solidFill>
                   <a:srgbClr val="52645B"/>
@@ -8959,6 +9416,7 @@
               </a:defRPr>
             </a:lvl1pPr>
             <a:lvl2pPr algn="l">
+              <a:buNone/>
               <a:defRPr sz="1650" b="0">
                 <a:solidFill>
                   <a:srgbClr val="52645B"/>
@@ -8969,6 +9427,7 @@
               </a:defRPr>
             </a:lvl2pPr>
             <a:lvl3pPr algn="l">
+              <a:buNone/>
               <a:defRPr sz="1650" b="0">
                 <a:solidFill>
                   <a:srgbClr val="52645B"/>
@@ -8979,6 +9438,7 @@
               </a:defRPr>
             </a:lvl3pPr>
             <a:lvl4pPr algn="l">
+              <a:buNone/>
               <a:defRPr sz="1650" b="0">
                 <a:solidFill>
                   <a:srgbClr val="52645B"/>
@@ -8989,6 +9449,7 @@
               </a:defRPr>
             </a:lvl4pPr>
             <a:lvl5pPr algn="l">
+              <a:buNone/>
               <a:defRPr sz="1650" b="0">
                 <a:solidFill>
                   <a:srgbClr val="52645B"/>
@@ -8999,6 +9460,7 @@
               </a:defRPr>
             </a:lvl5pPr>
             <a:lvl6pPr algn="l">
+              <a:buNone/>
               <a:defRPr sz="1650" b="0">
                 <a:solidFill>
                   <a:srgbClr val="52645B"/>
@@ -9009,6 +9471,7 @@
               </a:defRPr>
             </a:lvl6pPr>
             <a:lvl7pPr algn="l">
+              <a:buNone/>
               <a:defRPr sz="1650" b="0">
                 <a:solidFill>
                   <a:srgbClr val="52645B"/>
@@ -9019,6 +9482,7 @@
               </a:defRPr>
             </a:lvl7pPr>
             <a:lvl8pPr algn="l">
+              <a:buNone/>
               <a:defRPr sz="1650" b="0">
                 <a:solidFill>
                   <a:srgbClr val="52645B"/>
@@ -9029,6 +9493,7 @@
               </a:defRPr>
             </a:lvl8pPr>
             <a:lvl9pPr algn="l">
+              <a:buNone/>
               <a:defRPr sz="1650" b="0">
                 <a:solidFill>
                   <a:srgbClr val="52645B"/>
@@ -9041,6 +9506,7 @@
           </a:lstStyle>
           <a:p xmlns:a="http://schemas.openxmlformats.org/drawingml/2006/main">
             <a:pPr algn="l">
+              <a:buNone/>
               <a:defRPr sz="1650" b="0">
                 <a:solidFill>
                   <a:srgbClr val="52645B"/>
@@ -9137,6 +9603,7 @@
               </a:defRPr>
             </a:defPPr>
             <a:lvl1pPr algn="l">
+              <a:buNone/>
               <a:defRPr sz="2850" b="1">
                 <a:solidFill>
                   <a:srgbClr val="121513"/>
@@ -9147,6 +9614,7 @@
               </a:defRPr>
             </a:lvl1pPr>
             <a:lvl2pPr algn="l">
+              <a:buNone/>
               <a:defRPr sz="2850" b="1">
                 <a:solidFill>
                   <a:srgbClr val="121513"/>
@@ -9157,6 +9625,7 @@
               </a:defRPr>
             </a:lvl2pPr>
             <a:lvl3pPr algn="l">
+              <a:buNone/>
               <a:defRPr sz="2850" b="1">
                 <a:solidFill>
                   <a:srgbClr val="121513"/>
@@ -9167,6 +9636,7 @@
               </a:defRPr>
             </a:lvl3pPr>
             <a:lvl4pPr algn="l">
+              <a:buNone/>
               <a:defRPr sz="2850" b="1">
                 <a:solidFill>
                   <a:srgbClr val="121513"/>
@@ -9177,6 +9647,7 @@
               </a:defRPr>
             </a:lvl4pPr>
             <a:lvl5pPr algn="l">
+              <a:buNone/>
               <a:defRPr sz="2850" b="1">
                 <a:solidFill>
                   <a:srgbClr val="121513"/>
@@ -9187,6 +9658,7 @@
               </a:defRPr>
             </a:lvl5pPr>
             <a:lvl6pPr algn="l">
+              <a:buNone/>
               <a:defRPr sz="2850" b="1">
                 <a:solidFill>
                   <a:srgbClr val="121513"/>
@@ -9197,6 +9669,7 @@
               </a:defRPr>
             </a:lvl6pPr>
             <a:lvl7pPr algn="l">
+              <a:buNone/>
               <a:defRPr sz="2850" b="1">
                 <a:solidFill>
                   <a:srgbClr val="121513"/>
@@ -9207,6 +9680,7 @@
               </a:defRPr>
             </a:lvl7pPr>
             <a:lvl8pPr algn="l">
+              <a:buNone/>
               <a:defRPr sz="2850" b="1">
                 <a:solidFill>
                   <a:srgbClr val="121513"/>
@@ -9217,6 +9691,7 @@
               </a:defRPr>
             </a:lvl8pPr>
             <a:lvl9pPr algn="l">
+              <a:buNone/>
               <a:defRPr sz="2850" b="1">
                 <a:solidFill>
                   <a:srgbClr val="121513"/>
@@ -9229,6 +9704,7 @@
           </a:lstStyle>
           <a:p xmlns:a="http://schemas.openxmlformats.org/drawingml/2006/main">
             <a:pPr algn="l">
+              <a:buNone/>
               <a:defRPr sz="2850" b="1">
                 <a:solidFill>
                   <a:srgbClr val="121513"/>
@@ -9296,6 +9772,7 @@
               </a:defRPr>
             </a:defPPr>
             <a:lvl1pPr algn="l">
+              <a:buNone/>
               <a:defRPr sz="1575" b="0">
                 <a:solidFill>
                   <a:srgbClr val="207354"/>
@@ -9306,6 +9783,7 @@
               </a:defRPr>
             </a:lvl1pPr>
             <a:lvl2pPr algn="l">
+              <a:buNone/>
               <a:defRPr sz="1575" b="0">
                 <a:solidFill>
                   <a:srgbClr val="207354"/>
@@ -9316,6 +9794,7 @@
               </a:defRPr>
             </a:lvl2pPr>
             <a:lvl3pPr algn="l">
+              <a:buNone/>
               <a:defRPr sz="1575" b="0">
                 <a:solidFill>
                   <a:srgbClr val="207354"/>
@@ -9326,6 +9805,7 @@
               </a:defRPr>
             </a:lvl3pPr>
             <a:lvl4pPr algn="l">
+              <a:buNone/>
               <a:defRPr sz="1575" b="0">
                 <a:solidFill>
                   <a:srgbClr val="207354"/>
@@ -9336,6 +9816,7 @@
               </a:defRPr>
             </a:lvl4pPr>
             <a:lvl5pPr algn="l">
+              <a:buNone/>
               <a:defRPr sz="1575" b="0">
                 <a:solidFill>
                   <a:srgbClr val="207354"/>
@@ -9346,6 +9827,7 @@
               </a:defRPr>
             </a:lvl5pPr>
             <a:lvl6pPr algn="l">
+              <a:buNone/>
               <a:defRPr sz="1575" b="0">
                 <a:solidFill>
                   <a:srgbClr val="207354"/>
@@ -9356,6 +9838,7 @@
               </a:defRPr>
             </a:lvl6pPr>
             <a:lvl7pPr algn="l">
+              <a:buNone/>
               <a:defRPr sz="1575" b="0">
                 <a:solidFill>
                   <a:srgbClr val="207354"/>
@@ -9366,6 +9849,7 @@
               </a:defRPr>
             </a:lvl7pPr>
             <a:lvl8pPr algn="l">
+              <a:buNone/>
               <a:defRPr sz="1575" b="0">
                 <a:solidFill>
                   <a:srgbClr val="207354"/>
@@ -9376,6 +9860,7 @@
               </a:defRPr>
             </a:lvl8pPr>
             <a:lvl9pPr algn="l">
+              <a:buNone/>
               <a:defRPr sz="1575" b="0">
                 <a:solidFill>
                   <a:srgbClr val="207354"/>
@@ -9388,6 +9873,7 @@
           </a:lstStyle>
           <a:p xmlns:a="http://schemas.openxmlformats.org/drawingml/2006/main">
             <a:pPr algn="l">
+              <a:buNone/>
               <a:defRPr sz="1575" b="0">
                 <a:solidFill>
                   <a:srgbClr val="207354"/>
@@ -9455,6 +9941,7 @@
               </a:defRPr>
             </a:defPPr>
             <a:lvl1pPr algn="l">
+              <a:buNone/>
               <a:defRPr sz="2175" b="1">
                 <a:solidFill>
                   <a:srgbClr val="207354"/>
@@ -9465,6 +9952,7 @@
               </a:defRPr>
             </a:lvl1pPr>
             <a:lvl2pPr algn="l">
+              <a:buNone/>
               <a:defRPr sz="2175" b="1">
                 <a:solidFill>
                   <a:srgbClr val="207354"/>
@@ -9475,6 +9963,7 @@
               </a:defRPr>
             </a:lvl2pPr>
             <a:lvl3pPr algn="l">
+              <a:buNone/>
               <a:defRPr sz="2175" b="1">
                 <a:solidFill>
                   <a:srgbClr val="207354"/>
@@ -9485,6 +9974,7 @@
               </a:defRPr>
             </a:lvl3pPr>
             <a:lvl4pPr algn="l">
+              <a:buNone/>
               <a:defRPr sz="2175" b="1">
                 <a:solidFill>
                   <a:srgbClr val="207354"/>
@@ -9495,6 +9985,7 @@
               </a:defRPr>
             </a:lvl4pPr>
             <a:lvl5pPr algn="l">
+              <a:buNone/>
               <a:defRPr sz="2175" b="1">
                 <a:solidFill>
                   <a:srgbClr val="207354"/>
@@ -9505,6 +9996,7 @@
               </a:defRPr>
             </a:lvl5pPr>
             <a:lvl6pPr algn="l">
+              <a:buNone/>
               <a:defRPr sz="2175" b="1">
                 <a:solidFill>
                   <a:srgbClr val="207354"/>
@@ -9515,6 +10007,7 @@
               </a:defRPr>
             </a:lvl6pPr>
             <a:lvl7pPr algn="l">
+              <a:buNone/>
               <a:defRPr sz="2175" b="1">
                 <a:solidFill>
                   <a:srgbClr val="207354"/>
@@ -9525,6 +10018,7 @@
               </a:defRPr>
             </a:lvl7pPr>
             <a:lvl8pPr algn="l">
+              <a:buNone/>
               <a:defRPr sz="2175" b="1">
                 <a:solidFill>
                   <a:srgbClr val="207354"/>
@@ -9535,6 +10029,7 @@
               </a:defRPr>
             </a:lvl8pPr>
             <a:lvl9pPr algn="l">
+              <a:buNone/>
               <a:defRPr sz="2175" b="1">
                 <a:solidFill>
                   <a:srgbClr val="207354"/>
@@ -9547,6 +10042,7 @@
           </a:lstStyle>
           <a:p xmlns:a="http://schemas.openxmlformats.org/drawingml/2006/main">
             <a:pPr algn="l">
+              <a:buNone/>
               <a:defRPr sz="2175" b="1">
                 <a:solidFill>
                   <a:srgbClr val="207354"/>
@@ -9614,6 +10110,7 @@
               </a:defRPr>
             </a:defPPr>
             <a:lvl1pPr algn="l">
+              <a:buNone/>
               <a:defRPr sz="1800" b="0">
                 <a:solidFill>
                   <a:srgbClr val="17211C"/>
@@ -9624,6 +10121,7 @@
               </a:defRPr>
             </a:lvl1pPr>
             <a:lvl2pPr algn="l">
+              <a:buNone/>
               <a:defRPr sz="1800" b="0">
                 <a:solidFill>
                   <a:srgbClr val="17211C"/>
@@ -9634,6 +10132,7 @@
               </a:defRPr>
             </a:lvl2pPr>
             <a:lvl3pPr algn="l">
+              <a:buNone/>
               <a:defRPr sz="1800" b="0">
                 <a:solidFill>
                   <a:srgbClr val="17211C"/>
@@ -9644,6 +10143,7 @@
               </a:defRPr>
             </a:lvl3pPr>
             <a:lvl4pPr algn="l">
+              <a:buNone/>
               <a:defRPr sz="1800" b="0">
                 <a:solidFill>
                   <a:srgbClr val="17211C"/>
@@ -9654,6 +10154,7 @@
               </a:defRPr>
             </a:lvl4pPr>
             <a:lvl5pPr algn="l">
+              <a:buNone/>
               <a:defRPr sz="1800" b="0">
                 <a:solidFill>
                   <a:srgbClr val="17211C"/>
@@ -9664,6 +10165,7 @@
               </a:defRPr>
             </a:lvl5pPr>
             <a:lvl6pPr algn="l">
+              <a:buNone/>
               <a:defRPr sz="1800" b="0">
                 <a:solidFill>
                   <a:srgbClr val="17211C"/>
@@ -9674,6 +10176,7 @@
               </a:defRPr>
             </a:lvl6pPr>
             <a:lvl7pPr algn="l">
+              <a:buNone/>
               <a:defRPr sz="1800" b="0">
                 <a:solidFill>
                   <a:srgbClr val="17211C"/>
@@ -9684,6 +10187,7 @@
               </a:defRPr>
             </a:lvl7pPr>
             <a:lvl8pPr algn="l">
+              <a:buNone/>
               <a:defRPr sz="1800" b="0">
                 <a:solidFill>
                   <a:srgbClr val="17211C"/>
@@ -9694,6 +10198,7 @@
               </a:defRPr>
             </a:lvl8pPr>
             <a:lvl9pPr algn="l">
+              <a:buNone/>
               <a:defRPr sz="1800" b="0">
                 <a:solidFill>
                   <a:srgbClr val="17211C"/>
@@ -9706,6 +10211,7 @@
           </a:lstStyle>
           <a:p xmlns:a="http://schemas.openxmlformats.org/drawingml/2006/main">
             <a:pPr algn="l">
+              <a:buNone/>
               <a:defRPr sz="1800" b="0">
                 <a:solidFill>
                   <a:srgbClr val="17211C"/>
@@ -9729,6 +10235,7 @@
           </a:p>
           <a:p xmlns:a="http://schemas.openxmlformats.org/drawingml/2006/main">
             <a:pPr algn="l">
+              <a:buNone/>
               <a:defRPr sz="1800" b="0">
                 <a:solidFill>
                   <a:srgbClr val="17211C"/>
@@ -9796,6 +10303,7 @@
               </a:defRPr>
             </a:defPPr>
             <a:lvl1pPr algn="l">
+              <a:buNone/>
               <a:defRPr sz="2175" b="1">
                 <a:solidFill>
                   <a:srgbClr val="207354"/>
@@ -9806,6 +10314,7 @@
               </a:defRPr>
             </a:lvl1pPr>
             <a:lvl2pPr algn="l">
+              <a:buNone/>
               <a:defRPr sz="2175" b="1">
                 <a:solidFill>
                   <a:srgbClr val="207354"/>
@@ -9816,6 +10325,7 @@
               </a:defRPr>
             </a:lvl2pPr>
             <a:lvl3pPr algn="l">
+              <a:buNone/>
               <a:defRPr sz="2175" b="1">
                 <a:solidFill>
                   <a:srgbClr val="207354"/>
@@ -9826,6 +10336,7 @@
               </a:defRPr>
             </a:lvl3pPr>
             <a:lvl4pPr algn="l">
+              <a:buNone/>
               <a:defRPr sz="2175" b="1">
                 <a:solidFill>
                   <a:srgbClr val="207354"/>
@@ -9836,6 +10347,7 @@
               </a:defRPr>
             </a:lvl4pPr>
             <a:lvl5pPr algn="l">
+              <a:buNone/>
               <a:defRPr sz="2175" b="1">
                 <a:solidFill>
                   <a:srgbClr val="207354"/>
@@ -9846,6 +10358,7 @@
               </a:defRPr>
             </a:lvl5pPr>
             <a:lvl6pPr algn="l">
+              <a:buNone/>
               <a:defRPr sz="2175" b="1">
                 <a:solidFill>
                   <a:srgbClr val="207354"/>
@@ -9856,6 +10369,7 @@
               </a:defRPr>
             </a:lvl6pPr>
             <a:lvl7pPr algn="l">
+              <a:buNone/>
               <a:defRPr sz="2175" b="1">
                 <a:solidFill>
                   <a:srgbClr val="207354"/>
@@ -9866,6 +10380,7 @@
               </a:defRPr>
             </a:lvl7pPr>
             <a:lvl8pPr algn="l">
+              <a:buNone/>
               <a:defRPr sz="2175" b="1">
                 <a:solidFill>
                   <a:srgbClr val="207354"/>
@@ -9876,6 +10391,7 @@
               </a:defRPr>
             </a:lvl8pPr>
             <a:lvl9pPr algn="l">
+              <a:buNone/>
               <a:defRPr sz="2175" b="1">
                 <a:solidFill>
                   <a:srgbClr val="207354"/>
@@ -9888,6 +10404,7 @@
           </a:lstStyle>
           <a:p xmlns:a="http://schemas.openxmlformats.org/drawingml/2006/main">
             <a:pPr algn="l">
+              <a:buNone/>
               <a:defRPr sz="2175" b="1">
                 <a:solidFill>
                   <a:srgbClr val="207354"/>
@@ -9955,6 +10472,7 @@
               </a:defRPr>
             </a:defPPr>
             <a:lvl1pPr algn="l">
+              <a:buNone/>
               <a:defRPr sz="1800" b="0">
                 <a:solidFill>
                   <a:srgbClr val="17211C"/>
@@ -9965,6 +10483,7 @@
               </a:defRPr>
             </a:lvl1pPr>
             <a:lvl2pPr algn="l">
+              <a:buNone/>
               <a:defRPr sz="1800" b="0">
                 <a:solidFill>
                   <a:srgbClr val="17211C"/>
@@ -9975,6 +10494,7 @@
               </a:defRPr>
             </a:lvl2pPr>
             <a:lvl3pPr algn="l">
+              <a:buNone/>
               <a:defRPr sz="1800" b="0">
                 <a:solidFill>
                   <a:srgbClr val="17211C"/>
@@ -9985,6 +10505,7 @@
               </a:defRPr>
             </a:lvl3pPr>
             <a:lvl4pPr algn="l">
+              <a:buNone/>
               <a:defRPr sz="1800" b="0">
                 <a:solidFill>
                   <a:srgbClr val="17211C"/>
@@ -9995,6 +10516,7 @@
               </a:defRPr>
             </a:lvl4pPr>
             <a:lvl5pPr algn="l">
+              <a:buNone/>
               <a:defRPr sz="1800" b="0">
                 <a:solidFill>
                   <a:srgbClr val="17211C"/>
@@ -10005,6 +10527,7 @@
               </a:defRPr>
             </a:lvl5pPr>
             <a:lvl6pPr algn="l">
+              <a:buNone/>
               <a:defRPr sz="1800" b="0">
                 <a:solidFill>
                   <a:srgbClr val="17211C"/>
@@ -10015,6 +10538,7 @@
               </a:defRPr>
             </a:lvl6pPr>
             <a:lvl7pPr algn="l">
+              <a:buNone/>
               <a:defRPr sz="1800" b="0">
                 <a:solidFill>
                   <a:srgbClr val="17211C"/>
@@ -10025,6 +10549,7 @@
               </a:defRPr>
             </a:lvl7pPr>
             <a:lvl8pPr algn="l">
+              <a:buNone/>
               <a:defRPr sz="1800" b="0">
                 <a:solidFill>
                   <a:srgbClr val="17211C"/>
@@ -10035,6 +10560,7 @@
               </a:defRPr>
             </a:lvl8pPr>
             <a:lvl9pPr algn="l">
+              <a:buNone/>
               <a:defRPr sz="1800" b="0">
                 <a:solidFill>
                   <a:srgbClr val="17211C"/>
@@ -10047,6 +10573,7 @@
           </a:lstStyle>
           <a:p xmlns:a="http://schemas.openxmlformats.org/drawingml/2006/main">
             <a:pPr algn="l">
+              <a:buNone/>
               <a:defRPr sz="1800" b="0">
                 <a:solidFill>
                   <a:srgbClr val="17211C"/>
@@ -10070,6 +10597,7 @@
           </a:p>
           <a:p xmlns:a="http://schemas.openxmlformats.org/drawingml/2006/main">
             <a:pPr algn="l">
+              <a:buNone/>
               <a:defRPr sz="1800" b="0">
                 <a:solidFill>
                   <a:srgbClr val="17211C"/>
@@ -10137,6 +10665,7 @@
               </a:defRPr>
             </a:defPPr>
             <a:lvl1pPr algn="l">
+              <a:buNone/>
               <a:defRPr sz="2175" b="1">
                 <a:solidFill>
                   <a:srgbClr val="207354"/>
@@ -10147,6 +10676,7 @@
               </a:defRPr>
             </a:lvl1pPr>
             <a:lvl2pPr algn="l">
+              <a:buNone/>
               <a:defRPr sz="2175" b="1">
                 <a:solidFill>
                   <a:srgbClr val="207354"/>
@@ -10157,6 +10687,7 @@
               </a:defRPr>
             </a:lvl2pPr>
             <a:lvl3pPr algn="l">
+              <a:buNone/>
               <a:defRPr sz="2175" b="1">
                 <a:solidFill>
                   <a:srgbClr val="207354"/>
@@ -10167,6 +10698,7 @@
               </a:defRPr>
             </a:lvl3pPr>
             <a:lvl4pPr algn="l">
+              <a:buNone/>
               <a:defRPr sz="2175" b="1">
                 <a:solidFill>
                   <a:srgbClr val="207354"/>
@@ -10177,6 +10709,7 @@
               </a:defRPr>
             </a:lvl4pPr>
             <a:lvl5pPr algn="l">
+              <a:buNone/>
               <a:defRPr sz="2175" b="1">
                 <a:solidFill>
                   <a:srgbClr val="207354"/>
@@ -10187,6 +10720,7 @@
               </a:defRPr>
             </a:lvl5pPr>
             <a:lvl6pPr algn="l">
+              <a:buNone/>
               <a:defRPr sz="2175" b="1">
                 <a:solidFill>
                   <a:srgbClr val="207354"/>
@@ -10197,6 +10731,7 @@
               </a:defRPr>
             </a:lvl6pPr>
             <a:lvl7pPr algn="l">
+              <a:buNone/>
               <a:defRPr sz="2175" b="1">
                 <a:solidFill>
                   <a:srgbClr val="207354"/>
@@ -10207,6 +10742,7 @@
               </a:defRPr>
             </a:lvl7pPr>
             <a:lvl8pPr algn="l">
+              <a:buNone/>
               <a:defRPr sz="2175" b="1">
                 <a:solidFill>
                   <a:srgbClr val="207354"/>
@@ -10217,6 +10753,7 @@
               </a:defRPr>
             </a:lvl8pPr>
             <a:lvl9pPr algn="l">
+              <a:buNone/>
               <a:defRPr sz="2175" b="1">
                 <a:solidFill>
                   <a:srgbClr val="207354"/>
@@ -10229,6 +10766,7 @@
           </a:lstStyle>
           <a:p xmlns:a="http://schemas.openxmlformats.org/drawingml/2006/main">
             <a:pPr algn="l">
+              <a:buNone/>
               <a:defRPr sz="2175" b="1">
                 <a:solidFill>
                   <a:srgbClr val="207354"/>
@@ -10296,6 +10834,7 @@
               </a:defRPr>
             </a:defPPr>
             <a:lvl1pPr algn="l">
+              <a:buNone/>
               <a:defRPr sz="1800" b="0">
                 <a:solidFill>
                   <a:srgbClr val="17211C"/>
@@ -10306,6 +10845,7 @@
               </a:defRPr>
             </a:lvl1pPr>
             <a:lvl2pPr algn="l">
+              <a:buNone/>
               <a:defRPr sz="1800" b="0">
                 <a:solidFill>
                   <a:srgbClr val="17211C"/>
@@ -10316,6 +10856,7 @@
               </a:defRPr>
             </a:lvl2pPr>
             <a:lvl3pPr algn="l">
+              <a:buNone/>
               <a:defRPr sz="1800" b="0">
                 <a:solidFill>
                   <a:srgbClr val="17211C"/>
@@ -10326,6 +10867,7 @@
               </a:defRPr>
             </a:lvl3pPr>
             <a:lvl4pPr algn="l">
+              <a:buNone/>
               <a:defRPr sz="1800" b="0">
                 <a:solidFill>
                   <a:srgbClr val="17211C"/>
@@ -10336,6 +10878,7 @@
               </a:defRPr>
             </a:lvl4pPr>
             <a:lvl5pPr algn="l">
+              <a:buNone/>
               <a:defRPr sz="1800" b="0">
                 <a:solidFill>
                   <a:srgbClr val="17211C"/>
@@ -10346,6 +10889,7 @@
               </a:defRPr>
             </a:lvl5pPr>
             <a:lvl6pPr algn="l">
+              <a:buNone/>
               <a:defRPr sz="1800" b="0">
                 <a:solidFill>
                   <a:srgbClr val="17211C"/>
@@ -10356,6 +10900,7 @@
               </a:defRPr>
             </a:lvl6pPr>
             <a:lvl7pPr algn="l">
+              <a:buNone/>
               <a:defRPr sz="1800" b="0">
                 <a:solidFill>
                   <a:srgbClr val="17211C"/>
@@ -10366,6 +10911,7 @@
               </a:defRPr>
             </a:lvl7pPr>
             <a:lvl8pPr algn="l">
+              <a:buNone/>
               <a:defRPr sz="1800" b="0">
                 <a:solidFill>
                   <a:srgbClr val="17211C"/>
@@ -10376,6 +10922,7 @@
               </a:defRPr>
             </a:lvl8pPr>
             <a:lvl9pPr algn="l">
+              <a:buNone/>
               <a:defRPr sz="1800" b="0">
                 <a:solidFill>
                   <a:srgbClr val="17211C"/>
@@ -10388,6 +10935,7 @@
           </a:lstStyle>
           <a:p xmlns:a="http://schemas.openxmlformats.org/drawingml/2006/main">
             <a:pPr algn="l">
+              <a:buNone/>
               <a:defRPr sz="1800" b="0">
                 <a:solidFill>
                   <a:srgbClr val="17211C"/>
@@ -10411,6 +10959,7 @@
           </a:p>
           <a:p xmlns:a="http://schemas.openxmlformats.org/drawingml/2006/main">
             <a:pPr algn="l">
+              <a:buNone/>
               <a:defRPr sz="1800" b="0">
                 <a:solidFill>
                   <a:srgbClr val="17211C"/>
@@ -10478,6 +11027,7 @@
               </a:defRPr>
             </a:defPPr>
             <a:lvl1pPr algn="l">
+              <a:buNone/>
               <a:defRPr sz="1950" b="1">
                 <a:solidFill>
                   <a:srgbClr val="17211C"/>
@@ -10488,6 +11038,7 @@
               </a:defRPr>
             </a:lvl1pPr>
             <a:lvl2pPr algn="l">
+              <a:buNone/>
               <a:defRPr sz="1950" b="1">
                 <a:solidFill>
                   <a:srgbClr val="17211C"/>
@@ -10498,6 +11049,7 @@
               </a:defRPr>
             </a:lvl2pPr>
             <a:lvl3pPr algn="l">
+              <a:buNone/>
               <a:defRPr sz="1950" b="1">
                 <a:solidFill>
                   <a:srgbClr val="17211C"/>
@@ -10508,6 +11060,7 @@
               </a:defRPr>
             </a:lvl3pPr>
             <a:lvl4pPr algn="l">
+              <a:buNone/>
               <a:defRPr sz="1950" b="1">
                 <a:solidFill>
                   <a:srgbClr val="17211C"/>
@@ -10518,6 +11071,7 @@
               </a:defRPr>
             </a:lvl4pPr>
             <a:lvl5pPr algn="l">
+              <a:buNone/>
               <a:defRPr sz="1950" b="1">
                 <a:solidFill>
                   <a:srgbClr val="17211C"/>
@@ -10528,6 +11082,7 @@
               </a:defRPr>
             </a:lvl5pPr>
             <a:lvl6pPr algn="l">
+              <a:buNone/>
               <a:defRPr sz="1950" b="1">
                 <a:solidFill>
                   <a:srgbClr val="17211C"/>
@@ -10538,6 +11093,7 @@
               </a:defRPr>
             </a:lvl6pPr>
             <a:lvl7pPr algn="l">
+              <a:buNone/>
               <a:defRPr sz="1950" b="1">
                 <a:solidFill>
                   <a:srgbClr val="17211C"/>
@@ -10548,6 +11104,7 @@
               </a:defRPr>
             </a:lvl7pPr>
             <a:lvl8pPr algn="l">
+              <a:buNone/>
               <a:defRPr sz="1950" b="1">
                 <a:solidFill>
                   <a:srgbClr val="17211C"/>
@@ -10558,6 +11115,7 @@
               </a:defRPr>
             </a:lvl8pPr>
             <a:lvl9pPr algn="l">
+              <a:buNone/>
               <a:defRPr sz="1950" b="1">
                 <a:solidFill>
                   <a:srgbClr val="17211C"/>
@@ -10570,6 +11128,7 @@
           </a:lstStyle>
           <a:p xmlns:a="http://schemas.openxmlformats.org/drawingml/2006/main">
             <a:pPr algn="l">
+              <a:buNone/>
               <a:defRPr sz="1950" b="1">
                 <a:solidFill>
                   <a:srgbClr val="17211C"/>
@@ -10666,6 +11225,7 @@
               </a:defRPr>
             </a:defPPr>
             <a:lvl1pPr algn="l">
+              <a:buNone/>
               <a:defRPr sz="2850" b="1">
                 <a:solidFill>
                   <a:srgbClr val="E8F0EA"/>
@@ -10676,6 +11236,7 @@
               </a:defRPr>
             </a:lvl1pPr>
             <a:lvl2pPr algn="l">
+              <a:buNone/>
               <a:defRPr sz="2850" b="1">
                 <a:solidFill>
                   <a:srgbClr val="E8F0EA"/>
@@ -10686,6 +11247,7 @@
               </a:defRPr>
             </a:lvl2pPr>
             <a:lvl3pPr algn="l">
+              <a:buNone/>
               <a:defRPr sz="2850" b="1">
                 <a:solidFill>
                   <a:srgbClr val="E8F0EA"/>
@@ -10696,6 +11258,7 @@
               </a:defRPr>
             </a:lvl3pPr>
             <a:lvl4pPr algn="l">
+              <a:buNone/>
               <a:defRPr sz="2850" b="1">
                 <a:solidFill>
                   <a:srgbClr val="E8F0EA"/>
@@ -10706,6 +11269,7 @@
               </a:defRPr>
             </a:lvl4pPr>
             <a:lvl5pPr algn="l">
+              <a:buNone/>
               <a:defRPr sz="2850" b="1">
                 <a:solidFill>
                   <a:srgbClr val="E8F0EA"/>
@@ -10716,6 +11280,7 @@
               </a:defRPr>
             </a:lvl5pPr>
             <a:lvl6pPr algn="l">
+              <a:buNone/>
               <a:defRPr sz="2850" b="1">
                 <a:solidFill>
                   <a:srgbClr val="E8F0EA"/>
@@ -10726,6 +11291,7 @@
               </a:defRPr>
             </a:lvl6pPr>
             <a:lvl7pPr algn="l">
+              <a:buNone/>
               <a:defRPr sz="2850" b="1">
                 <a:solidFill>
                   <a:srgbClr val="E8F0EA"/>
@@ -10736,6 +11302,7 @@
               </a:defRPr>
             </a:lvl7pPr>
             <a:lvl8pPr algn="l">
+              <a:buNone/>
               <a:defRPr sz="2850" b="1">
                 <a:solidFill>
                   <a:srgbClr val="E8F0EA"/>
@@ -10746,6 +11313,7 @@
               </a:defRPr>
             </a:lvl8pPr>
             <a:lvl9pPr algn="l">
+              <a:buNone/>
               <a:defRPr sz="2850" b="1">
                 <a:solidFill>
                   <a:srgbClr val="E8F0EA"/>
@@ -10758,6 +11326,7 @@
           </a:lstStyle>
           <a:p xmlns:a="http://schemas.openxmlformats.org/drawingml/2006/main">
             <a:pPr algn="l">
+              <a:buNone/>
               <a:defRPr sz="2850" b="1">
                 <a:solidFill>
                   <a:srgbClr val="E8F0EA"/>
@@ -10825,6 +11394,7 @@
               </a:defRPr>
             </a:defPPr>
             <a:lvl1pPr algn="l">
+              <a:buNone/>
               <a:defRPr sz="1575" b="0">
                 <a:solidFill>
                   <a:srgbClr val="78DEB6"/>
@@ -10835,6 +11405,7 @@
               </a:defRPr>
             </a:lvl1pPr>
             <a:lvl2pPr algn="l">
+              <a:buNone/>
               <a:defRPr sz="1575" b="0">
                 <a:solidFill>
                   <a:srgbClr val="78DEB6"/>
@@ -10845,6 +11416,7 @@
               </a:defRPr>
             </a:lvl2pPr>
             <a:lvl3pPr algn="l">
+              <a:buNone/>
               <a:defRPr sz="1575" b="0">
                 <a:solidFill>
                   <a:srgbClr val="78DEB6"/>
@@ -10855,6 +11427,7 @@
               </a:defRPr>
             </a:lvl3pPr>
             <a:lvl4pPr algn="l">
+              <a:buNone/>
               <a:defRPr sz="1575" b="0">
                 <a:solidFill>
                   <a:srgbClr val="78DEB6"/>
@@ -10865,6 +11438,7 @@
               </a:defRPr>
             </a:lvl4pPr>
             <a:lvl5pPr algn="l">
+              <a:buNone/>
               <a:defRPr sz="1575" b="0">
                 <a:solidFill>
                   <a:srgbClr val="78DEB6"/>
@@ -10875,6 +11449,7 @@
               </a:defRPr>
             </a:lvl5pPr>
             <a:lvl6pPr algn="l">
+              <a:buNone/>
               <a:defRPr sz="1575" b="0">
                 <a:solidFill>
                   <a:srgbClr val="78DEB6"/>
@@ -10885,6 +11460,7 @@
               </a:defRPr>
             </a:lvl6pPr>
             <a:lvl7pPr algn="l">
+              <a:buNone/>
               <a:defRPr sz="1575" b="0">
                 <a:solidFill>
                   <a:srgbClr val="78DEB6"/>
@@ -10895,6 +11471,7 @@
               </a:defRPr>
             </a:lvl7pPr>
             <a:lvl8pPr algn="l">
+              <a:buNone/>
               <a:defRPr sz="1575" b="0">
                 <a:solidFill>
                   <a:srgbClr val="78DEB6"/>
@@ -10905,6 +11482,7 @@
               </a:defRPr>
             </a:lvl8pPr>
             <a:lvl9pPr algn="l">
+              <a:buNone/>
               <a:defRPr sz="1575" b="0">
                 <a:solidFill>
                   <a:srgbClr val="78DEB6"/>
@@ -10917,6 +11495,7 @@
           </a:lstStyle>
           <a:p xmlns:a="http://schemas.openxmlformats.org/drawingml/2006/main">
             <a:pPr algn="l">
+              <a:buNone/>
               <a:defRPr sz="1575" b="0">
                 <a:solidFill>
                   <a:srgbClr val="78DEB6"/>
@@ -10984,6 +11563,7 @@
               </a:defRPr>
             </a:defPPr>
             <a:lvl1pPr algn="l">
+              <a:buNone/>
               <a:defRPr sz="7350" b="1">
                 <a:solidFill>
                   <a:srgbClr val="78DEB6"/>
@@ -10994,6 +11574,7 @@
               </a:defRPr>
             </a:lvl1pPr>
             <a:lvl2pPr algn="l">
+              <a:buNone/>
               <a:defRPr sz="7350" b="1">
                 <a:solidFill>
                   <a:srgbClr val="78DEB6"/>
@@ -11004,6 +11585,7 @@
               </a:defRPr>
             </a:lvl2pPr>
             <a:lvl3pPr algn="l">
+              <a:buNone/>
               <a:defRPr sz="7350" b="1">
                 <a:solidFill>
                   <a:srgbClr val="78DEB6"/>
@@ -11014,6 +11596,7 @@
               </a:defRPr>
             </a:lvl3pPr>
             <a:lvl4pPr algn="l">
+              <a:buNone/>
               <a:defRPr sz="7350" b="1">
                 <a:solidFill>
                   <a:srgbClr val="78DEB6"/>
@@ -11024,6 +11607,7 @@
               </a:defRPr>
             </a:lvl4pPr>
             <a:lvl5pPr algn="l">
+              <a:buNone/>
               <a:defRPr sz="7350" b="1">
                 <a:solidFill>
                   <a:srgbClr val="78DEB6"/>
@@ -11034,6 +11618,7 @@
               </a:defRPr>
             </a:lvl5pPr>
             <a:lvl6pPr algn="l">
+              <a:buNone/>
               <a:defRPr sz="7350" b="1">
                 <a:solidFill>
                   <a:srgbClr val="78DEB6"/>
@@ -11044,6 +11629,7 @@
               </a:defRPr>
             </a:lvl6pPr>
             <a:lvl7pPr algn="l">
+              <a:buNone/>
               <a:defRPr sz="7350" b="1">
                 <a:solidFill>
                   <a:srgbClr val="78DEB6"/>
@@ -11054,6 +11640,7 @@
               </a:defRPr>
             </a:lvl7pPr>
             <a:lvl8pPr algn="l">
+              <a:buNone/>
               <a:defRPr sz="7350" b="1">
                 <a:solidFill>
                   <a:srgbClr val="78DEB6"/>
@@ -11064,6 +11651,7 @@
               </a:defRPr>
             </a:lvl8pPr>
             <a:lvl9pPr algn="l">
+              <a:buNone/>
               <a:defRPr sz="7350" b="1">
                 <a:solidFill>
                   <a:srgbClr val="78DEB6"/>
@@ -11076,6 +11664,7 @@
           </a:lstStyle>
           <a:p xmlns:a="http://schemas.openxmlformats.org/drawingml/2006/main">
             <a:pPr algn="l">
+              <a:buNone/>
               <a:defRPr sz="7350" b="1">
                 <a:solidFill>
                   <a:srgbClr val="78DEB6"/>
@@ -11143,6 +11732,7 @@
               </a:defRPr>
             </a:defPPr>
             <a:lvl1pPr algn="l">
+              <a:buNone/>
               <a:defRPr sz="2100" b="0">
                 <a:solidFill>
                   <a:srgbClr val="E8F0EA"/>
@@ -11153,6 +11743,7 @@
               </a:defRPr>
             </a:lvl1pPr>
             <a:lvl2pPr algn="l">
+              <a:buNone/>
               <a:defRPr sz="2100" b="0">
                 <a:solidFill>
                   <a:srgbClr val="E8F0EA"/>
@@ -11163,6 +11754,7 @@
               </a:defRPr>
             </a:lvl2pPr>
             <a:lvl3pPr algn="l">
+              <a:buNone/>
               <a:defRPr sz="2100" b="0">
                 <a:solidFill>
                   <a:srgbClr val="E8F0EA"/>
@@ -11173,6 +11765,7 @@
               </a:defRPr>
             </a:lvl3pPr>
             <a:lvl4pPr algn="l">
+              <a:buNone/>
               <a:defRPr sz="2100" b="0">
                 <a:solidFill>
                   <a:srgbClr val="E8F0EA"/>
@@ -11183,6 +11776,7 @@
               </a:defRPr>
             </a:lvl4pPr>
             <a:lvl5pPr algn="l">
+              <a:buNone/>
               <a:defRPr sz="2100" b="0">
                 <a:solidFill>
                   <a:srgbClr val="E8F0EA"/>
@@ -11193,6 +11787,7 @@
               </a:defRPr>
             </a:lvl5pPr>
             <a:lvl6pPr algn="l">
+              <a:buNone/>
               <a:defRPr sz="2100" b="0">
                 <a:solidFill>
                   <a:srgbClr val="E8F0EA"/>
@@ -11203,6 +11798,7 @@
               </a:defRPr>
             </a:lvl6pPr>
             <a:lvl7pPr algn="l">
+              <a:buNone/>
               <a:defRPr sz="2100" b="0">
                 <a:solidFill>
                   <a:srgbClr val="E8F0EA"/>
@@ -11213,6 +11809,7 @@
               </a:defRPr>
             </a:lvl7pPr>
             <a:lvl8pPr algn="l">
+              <a:buNone/>
               <a:defRPr sz="2100" b="0">
                 <a:solidFill>
                   <a:srgbClr val="E8F0EA"/>
@@ -11223,6 +11820,7 @@
               </a:defRPr>
             </a:lvl8pPr>
             <a:lvl9pPr algn="l">
+              <a:buNone/>
               <a:defRPr sz="2100" b="0">
                 <a:solidFill>
                   <a:srgbClr val="E8F0EA"/>
@@ -11235,6 +11833,7 @@
           </a:lstStyle>
           <a:p xmlns:a="http://schemas.openxmlformats.org/drawingml/2006/main">
             <a:pPr algn="l">
+              <a:buNone/>
               <a:defRPr sz="2100" b="0">
                 <a:solidFill>
                   <a:srgbClr val="E8F0EA"/>
@@ -11302,6 +11901,7 @@
               </a:defRPr>
             </a:defPPr>
             <a:lvl1pPr algn="l">
+              <a:buNone/>
               <a:defRPr sz="7350" b="1">
                 <a:solidFill>
                   <a:srgbClr val="78DEB6"/>
@@ -11312,6 +11912,7 @@
               </a:defRPr>
             </a:lvl1pPr>
             <a:lvl2pPr algn="l">
+              <a:buNone/>
               <a:defRPr sz="7350" b="1">
                 <a:solidFill>
                   <a:srgbClr val="78DEB6"/>
@@ -11322,6 +11923,7 @@
               </a:defRPr>
             </a:lvl2pPr>
             <a:lvl3pPr algn="l">
+              <a:buNone/>
               <a:defRPr sz="7350" b="1">
                 <a:solidFill>
                   <a:srgbClr val="78DEB6"/>
@@ -11332,6 +11934,7 @@
               </a:defRPr>
             </a:lvl3pPr>
             <a:lvl4pPr algn="l">
+              <a:buNone/>
               <a:defRPr sz="7350" b="1">
                 <a:solidFill>
                   <a:srgbClr val="78DEB6"/>
@@ -11342,6 +11945,7 @@
               </a:defRPr>
             </a:lvl4pPr>
             <a:lvl5pPr algn="l">
+              <a:buNone/>
               <a:defRPr sz="7350" b="1">
                 <a:solidFill>
                   <a:srgbClr val="78DEB6"/>
@@ -11352,6 +11956,7 @@
               </a:defRPr>
             </a:lvl5pPr>
             <a:lvl6pPr algn="l">
+              <a:buNone/>
               <a:defRPr sz="7350" b="1">
                 <a:solidFill>
                   <a:srgbClr val="78DEB6"/>
@@ -11362,6 +11967,7 @@
               </a:defRPr>
             </a:lvl6pPr>
             <a:lvl7pPr algn="l">
+              <a:buNone/>
               <a:defRPr sz="7350" b="1">
                 <a:solidFill>
                   <a:srgbClr val="78DEB6"/>
@@ -11372,6 +11978,7 @@
               </a:defRPr>
             </a:lvl7pPr>
             <a:lvl8pPr algn="l">
+              <a:buNone/>
               <a:defRPr sz="7350" b="1">
                 <a:solidFill>
                   <a:srgbClr val="78DEB6"/>
@@ -11382,6 +11989,7 @@
               </a:defRPr>
             </a:lvl8pPr>
             <a:lvl9pPr algn="l">
+              <a:buNone/>
               <a:defRPr sz="7350" b="1">
                 <a:solidFill>
                   <a:srgbClr val="78DEB6"/>
@@ -11394,6 +12002,7 @@
           </a:lstStyle>
           <a:p xmlns:a="http://schemas.openxmlformats.org/drawingml/2006/main">
             <a:pPr algn="l">
+              <a:buNone/>
               <a:defRPr sz="7350" b="1">
                 <a:solidFill>
                   <a:srgbClr val="78DEB6"/>
@@ -11461,6 +12070,7 @@
               </a:defRPr>
             </a:defPPr>
             <a:lvl1pPr algn="l">
+              <a:buNone/>
               <a:defRPr sz="2100" b="0">
                 <a:solidFill>
                   <a:srgbClr val="E8F0EA"/>
@@ -11471,6 +12081,7 @@
               </a:defRPr>
             </a:lvl1pPr>
             <a:lvl2pPr algn="l">
+              <a:buNone/>
               <a:defRPr sz="2100" b="0">
                 <a:solidFill>
                   <a:srgbClr val="E8F0EA"/>
@@ -11481,6 +12092,7 @@
               </a:defRPr>
             </a:lvl2pPr>
             <a:lvl3pPr algn="l">
+              <a:buNone/>
               <a:defRPr sz="2100" b="0">
                 <a:solidFill>
                   <a:srgbClr val="E8F0EA"/>
@@ -11491,6 +12103,7 @@
               </a:defRPr>
             </a:lvl3pPr>
             <a:lvl4pPr algn="l">
+              <a:buNone/>
               <a:defRPr sz="2100" b="0">
                 <a:solidFill>
                   <a:srgbClr val="E8F0EA"/>
@@ -11501,6 +12114,7 @@
               </a:defRPr>
             </a:lvl4pPr>
             <a:lvl5pPr algn="l">
+              <a:buNone/>
               <a:defRPr sz="2100" b="0">
                 <a:solidFill>
                   <a:srgbClr val="E8F0EA"/>
@@ -11511,6 +12125,7 @@
               </a:defRPr>
             </a:lvl5pPr>
             <a:lvl6pPr algn="l">
+              <a:buNone/>
               <a:defRPr sz="2100" b="0">
                 <a:solidFill>
                   <a:srgbClr val="E8F0EA"/>
@@ -11521,6 +12136,7 @@
               </a:defRPr>
             </a:lvl6pPr>
             <a:lvl7pPr algn="l">
+              <a:buNone/>
               <a:defRPr sz="2100" b="0">
                 <a:solidFill>
                   <a:srgbClr val="E8F0EA"/>
@@ -11531,6 +12147,7 @@
               </a:defRPr>
             </a:lvl7pPr>
             <a:lvl8pPr algn="l">
+              <a:buNone/>
               <a:defRPr sz="2100" b="0">
                 <a:solidFill>
                   <a:srgbClr val="E8F0EA"/>
@@ -11541,6 +12158,7 @@
               </a:defRPr>
             </a:lvl8pPr>
             <a:lvl9pPr algn="l">
+              <a:buNone/>
               <a:defRPr sz="2100" b="0">
                 <a:solidFill>
                   <a:srgbClr val="E8F0EA"/>
@@ -11553,6 +12171,7 @@
           </a:lstStyle>
           <a:p xmlns:a="http://schemas.openxmlformats.org/drawingml/2006/main">
             <a:pPr algn="l">
+              <a:buNone/>
               <a:defRPr sz="2100" b="0">
                 <a:solidFill>
                   <a:srgbClr val="E8F0EA"/>
@@ -11620,6 +12239,7 @@
               </a:defRPr>
             </a:defPPr>
             <a:lvl1pPr algn="l">
+              <a:buNone/>
               <a:defRPr sz="5850" b="1">
                 <a:solidFill>
                   <a:srgbClr val="78DEB6"/>
@@ -11630,6 +12250,7 @@
               </a:defRPr>
             </a:lvl1pPr>
             <a:lvl2pPr algn="l">
+              <a:buNone/>
               <a:defRPr sz="5850" b="1">
                 <a:solidFill>
                   <a:srgbClr val="78DEB6"/>
@@ -11640,6 +12261,7 @@
               </a:defRPr>
             </a:lvl2pPr>
             <a:lvl3pPr algn="l">
+              <a:buNone/>
               <a:defRPr sz="5850" b="1">
                 <a:solidFill>
                   <a:srgbClr val="78DEB6"/>
@@ -11650,6 +12272,7 @@
               </a:defRPr>
             </a:lvl3pPr>
             <a:lvl4pPr algn="l">
+              <a:buNone/>
               <a:defRPr sz="5850" b="1">
                 <a:solidFill>
                   <a:srgbClr val="78DEB6"/>
@@ -11660,6 +12283,7 @@
               </a:defRPr>
             </a:lvl4pPr>
             <a:lvl5pPr algn="l">
+              <a:buNone/>
               <a:defRPr sz="5850" b="1">
                 <a:solidFill>
                   <a:srgbClr val="78DEB6"/>
@@ -11670,6 +12294,7 @@
               </a:defRPr>
             </a:lvl5pPr>
             <a:lvl6pPr algn="l">
+              <a:buNone/>
               <a:defRPr sz="5850" b="1">
                 <a:solidFill>
                   <a:srgbClr val="78DEB6"/>
@@ -11680,6 +12305,7 @@
               </a:defRPr>
             </a:lvl6pPr>
             <a:lvl7pPr algn="l">
+              <a:buNone/>
               <a:defRPr sz="5850" b="1">
                 <a:solidFill>
                   <a:srgbClr val="78DEB6"/>
@@ -11690,6 +12316,7 @@
               </a:defRPr>
             </a:lvl7pPr>
             <a:lvl8pPr algn="l">
+              <a:buNone/>
               <a:defRPr sz="5850" b="1">
                 <a:solidFill>
                   <a:srgbClr val="78DEB6"/>
@@ -11700,6 +12327,7 @@
               </a:defRPr>
             </a:lvl8pPr>
             <a:lvl9pPr algn="l">
+              <a:buNone/>
               <a:defRPr sz="5850" b="1">
                 <a:solidFill>
                   <a:srgbClr val="78DEB6"/>
@@ -11712,6 +12340,7 @@
           </a:lstStyle>
           <a:p xmlns:a="http://schemas.openxmlformats.org/drawingml/2006/main">
             <a:pPr algn="l">
+              <a:buNone/>
               <a:defRPr sz="5850" b="1">
                 <a:solidFill>
                   <a:srgbClr val="78DEB6"/>
@@ -11779,6 +12408,7 @@
               </a:defRPr>
             </a:defPPr>
             <a:lvl1pPr algn="l">
+              <a:buNone/>
               <a:defRPr sz="1800" b="0">
                 <a:solidFill>
                   <a:srgbClr val="E8F0EA"/>
@@ -11789,6 +12419,7 @@
               </a:defRPr>
             </a:lvl1pPr>
             <a:lvl2pPr algn="l">
+              <a:buNone/>
               <a:defRPr sz="1800" b="0">
                 <a:solidFill>
                   <a:srgbClr val="E8F0EA"/>
@@ -11799,6 +12430,7 @@
               </a:defRPr>
             </a:lvl2pPr>
             <a:lvl3pPr algn="l">
+              <a:buNone/>
               <a:defRPr sz="1800" b="0">
                 <a:solidFill>
                   <a:srgbClr val="E8F0EA"/>
@@ -11809,6 +12441,7 @@
               </a:defRPr>
             </a:lvl3pPr>
             <a:lvl4pPr algn="l">
+              <a:buNone/>
               <a:defRPr sz="1800" b="0">
                 <a:solidFill>
                   <a:srgbClr val="E8F0EA"/>
@@ -11819,6 +12452,7 @@
               </a:defRPr>
             </a:lvl4pPr>
             <a:lvl5pPr algn="l">
+              <a:buNone/>
               <a:defRPr sz="1800" b="0">
                 <a:solidFill>
                   <a:srgbClr val="E8F0EA"/>
@@ -11829,6 +12463,7 @@
               </a:defRPr>
             </a:lvl5pPr>
             <a:lvl6pPr algn="l">
+              <a:buNone/>
               <a:defRPr sz="1800" b="0">
                 <a:solidFill>
                   <a:srgbClr val="E8F0EA"/>
@@ -11839,6 +12474,7 @@
               </a:defRPr>
             </a:lvl6pPr>
             <a:lvl7pPr algn="l">
+              <a:buNone/>
               <a:defRPr sz="1800" b="0">
                 <a:solidFill>
                   <a:srgbClr val="E8F0EA"/>
@@ -11849,6 +12485,7 @@
               </a:defRPr>
             </a:lvl7pPr>
             <a:lvl8pPr algn="l">
+              <a:buNone/>
               <a:defRPr sz="1800" b="0">
                 <a:solidFill>
                   <a:srgbClr val="E8F0EA"/>
@@ -11859,6 +12496,7 @@
               </a:defRPr>
             </a:lvl8pPr>
             <a:lvl9pPr algn="l">
+              <a:buNone/>
               <a:defRPr sz="1800" b="0">
                 <a:solidFill>
                   <a:srgbClr val="E8F0EA"/>
@@ -11871,6 +12509,7 @@
           </a:lstStyle>
           <a:p xmlns:a="http://schemas.openxmlformats.org/drawingml/2006/main">
             <a:pPr algn="l">
+              <a:buNone/>
               <a:defRPr sz="1800" b="0">
                 <a:solidFill>
                   <a:srgbClr val="E8F0EA"/>
@@ -11938,6 +12577,7 @@
               </a:defRPr>
             </a:defPPr>
             <a:lvl1pPr algn="l">
+              <a:buNone/>
               <a:defRPr sz="1875" b="0">
                 <a:solidFill>
                   <a:srgbClr val="E8F0EA"/>
@@ -11948,6 +12588,7 @@
               </a:defRPr>
             </a:lvl1pPr>
             <a:lvl2pPr algn="l">
+              <a:buNone/>
               <a:defRPr sz="1875" b="0">
                 <a:solidFill>
                   <a:srgbClr val="E8F0EA"/>
@@ -11958,6 +12599,7 @@
               </a:defRPr>
             </a:lvl2pPr>
             <a:lvl3pPr algn="l">
+              <a:buNone/>
               <a:defRPr sz="1875" b="0">
                 <a:solidFill>
                   <a:srgbClr val="E8F0EA"/>
@@ -11968,6 +12610,7 @@
               </a:defRPr>
             </a:lvl3pPr>
             <a:lvl4pPr algn="l">
+              <a:buNone/>
               <a:defRPr sz="1875" b="0">
                 <a:solidFill>
                   <a:srgbClr val="E8F0EA"/>
@@ -11978,6 +12621,7 @@
               </a:defRPr>
             </a:lvl4pPr>
             <a:lvl5pPr algn="l">
+              <a:buNone/>
               <a:defRPr sz="1875" b="0">
                 <a:solidFill>
                   <a:srgbClr val="E8F0EA"/>
@@ -11988,6 +12632,7 @@
               </a:defRPr>
             </a:lvl5pPr>
             <a:lvl6pPr algn="l">
+              <a:buNone/>
               <a:defRPr sz="1875" b="0">
                 <a:solidFill>
                   <a:srgbClr val="E8F0EA"/>
@@ -11998,6 +12643,7 @@
               </a:defRPr>
             </a:lvl6pPr>
             <a:lvl7pPr algn="l">
+              <a:buNone/>
               <a:defRPr sz="1875" b="0">
                 <a:solidFill>
                   <a:srgbClr val="E8F0EA"/>
@@ -12008,6 +12654,7 @@
               </a:defRPr>
             </a:lvl7pPr>
             <a:lvl8pPr algn="l">
+              <a:buNone/>
               <a:defRPr sz="1875" b="0">
                 <a:solidFill>
                   <a:srgbClr val="E8F0EA"/>
@@ -12018,6 +12665,7 @@
               </a:defRPr>
             </a:lvl8pPr>
             <a:lvl9pPr algn="l">
+              <a:buNone/>
               <a:defRPr sz="1875" b="0">
                 <a:solidFill>
                   <a:srgbClr val="E8F0EA"/>
@@ -12030,6 +12678,7 @@
           </a:lstStyle>
           <a:p xmlns:a="http://schemas.openxmlformats.org/drawingml/2006/main">
             <a:pPr algn="l">
+              <a:buNone/>
               <a:defRPr sz="1875" b="0">
                 <a:solidFill>
                   <a:srgbClr val="E8F0EA"/>
@@ -12126,6 +12775,7 @@
               </a:defRPr>
             </a:defPPr>
             <a:lvl1pPr algn="l">
+              <a:buNone/>
               <a:defRPr sz="2850" b="1">
                 <a:solidFill>
                   <a:srgbClr val="121513"/>
@@ -12136,6 +12786,7 @@
               </a:defRPr>
             </a:lvl1pPr>
             <a:lvl2pPr algn="l">
+              <a:buNone/>
               <a:defRPr sz="2850" b="1">
                 <a:solidFill>
                   <a:srgbClr val="121513"/>
@@ -12146,6 +12797,7 @@
               </a:defRPr>
             </a:lvl2pPr>
             <a:lvl3pPr algn="l">
+              <a:buNone/>
               <a:defRPr sz="2850" b="1">
                 <a:solidFill>
                   <a:srgbClr val="121513"/>
@@ -12156,6 +12808,7 @@
               </a:defRPr>
             </a:lvl3pPr>
             <a:lvl4pPr algn="l">
+              <a:buNone/>
               <a:defRPr sz="2850" b="1">
                 <a:solidFill>
                   <a:srgbClr val="121513"/>
@@ -12166,6 +12819,7 @@
               </a:defRPr>
             </a:lvl4pPr>
             <a:lvl5pPr algn="l">
+              <a:buNone/>
               <a:defRPr sz="2850" b="1">
                 <a:solidFill>
                   <a:srgbClr val="121513"/>
@@ -12176,6 +12830,7 @@
               </a:defRPr>
             </a:lvl5pPr>
             <a:lvl6pPr algn="l">
+              <a:buNone/>
               <a:defRPr sz="2850" b="1">
                 <a:solidFill>
                   <a:srgbClr val="121513"/>
@@ -12186,6 +12841,7 @@
               </a:defRPr>
             </a:lvl6pPr>
             <a:lvl7pPr algn="l">
+              <a:buNone/>
               <a:defRPr sz="2850" b="1">
                 <a:solidFill>
                   <a:srgbClr val="121513"/>
@@ -12196,6 +12852,7 @@
               </a:defRPr>
             </a:lvl7pPr>
             <a:lvl8pPr algn="l">
+              <a:buNone/>
               <a:defRPr sz="2850" b="1">
                 <a:solidFill>
                   <a:srgbClr val="121513"/>
@@ -12206,6 +12863,7 @@
               </a:defRPr>
             </a:lvl8pPr>
             <a:lvl9pPr algn="l">
+              <a:buNone/>
               <a:defRPr sz="2850" b="1">
                 <a:solidFill>
                   <a:srgbClr val="121513"/>
@@ -12218,6 +12876,7 @@
           </a:lstStyle>
           <a:p xmlns:a="http://schemas.openxmlformats.org/drawingml/2006/main">
             <a:pPr algn="l">
+              <a:buNone/>
               <a:defRPr sz="2850" b="1">
                 <a:solidFill>
                   <a:srgbClr val="121513"/>
@@ -12285,6 +12944,7 @@
               </a:defRPr>
             </a:defPPr>
             <a:lvl1pPr algn="l">
+              <a:buNone/>
               <a:defRPr sz="1575" b="0">
                 <a:solidFill>
                   <a:srgbClr val="207354"/>
@@ -12295,6 +12955,7 @@
               </a:defRPr>
             </a:lvl1pPr>
             <a:lvl2pPr algn="l">
+              <a:buNone/>
               <a:defRPr sz="1575" b="0">
                 <a:solidFill>
                   <a:srgbClr val="207354"/>
@@ -12305,6 +12966,7 @@
               </a:defRPr>
             </a:lvl2pPr>
             <a:lvl3pPr algn="l">
+              <a:buNone/>
               <a:defRPr sz="1575" b="0">
                 <a:solidFill>
                   <a:srgbClr val="207354"/>
@@ -12315,6 +12977,7 @@
               </a:defRPr>
             </a:lvl3pPr>
             <a:lvl4pPr algn="l">
+              <a:buNone/>
               <a:defRPr sz="1575" b="0">
                 <a:solidFill>
                   <a:srgbClr val="207354"/>
@@ -12325,6 +12988,7 @@
               </a:defRPr>
             </a:lvl4pPr>
             <a:lvl5pPr algn="l">
+              <a:buNone/>
               <a:defRPr sz="1575" b="0">
                 <a:solidFill>
                   <a:srgbClr val="207354"/>
@@ -12335,6 +12999,7 @@
               </a:defRPr>
             </a:lvl5pPr>
             <a:lvl6pPr algn="l">
+              <a:buNone/>
               <a:defRPr sz="1575" b="0">
                 <a:solidFill>
                   <a:srgbClr val="207354"/>
@@ -12345,6 +13010,7 @@
               </a:defRPr>
             </a:lvl6pPr>
             <a:lvl7pPr algn="l">
+              <a:buNone/>
               <a:defRPr sz="1575" b="0">
                 <a:solidFill>
                   <a:srgbClr val="207354"/>
@@ -12355,6 +13021,7 @@
               </a:defRPr>
             </a:lvl7pPr>
             <a:lvl8pPr algn="l">
+              <a:buNone/>
               <a:defRPr sz="1575" b="0">
                 <a:solidFill>
                   <a:srgbClr val="207354"/>
@@ -12365,6 +13032,7 @@
               </a:defRPr>
             </a:lvl8pPr>
             <a:lvl9pPr algn="l">
+              <a:buNone/>
               <a:defRPr sz="1575" b="0">
                 <a:solidFill>
                   <a:srgbClr val="207354"/>
@@ -12377,6 +13045,7 @@
           </a:lstStyle>
           <a:p xmlns:a="http://schemas.openxmlformats.org/drawingml/2006/main">
             <a:pPr algn="l">
+              <a:buNone/>
               <a:defRPr sz="1575" b="0">
                 <a:solidFill>
                   <a:srgbClr val="207354"/>
@@ -12444,6 +13113,7 @@
               </a:defRPr>
             </a:defPPr>
             <a:lvl1pPr algn="l">
+              <a:buNone/>
               <a:defRPr sz="2475" b="1">
                 <a:solidFill>
                   <a:srgbClr val="207354"/>
@@ -12454,6 +13124,7 @@
               </a:defRPr>
             </a:lvl1pPr>
             <a:lvl2pPr algn="l">
+              <a:buNone/>
               <a:defRPr sz="2475" b="1">
                 <a:solidFill>
                   <a:srgbClr val="207354"/>
@@ -12464,6 +13135,7 @@
               </a:defRPr>
             </a:lvl2pPr>
             <a:lvl3pPr algn="l">
+              <a:buNone/>
               <a:defRPr sz="2475" b="1">
                 <a:solidFill>
                   <a:srgbClr val="207354"/>
@@ -12474,6 +13146,7 @@
               </a:defRPr>
             </a:lvl3pPr>
             <a:lvl4pPr algn="l">
+              <a:buNone/>
               <a:defRPr sz="2475" b="1">
                 <a:solidFill>
                   <a:srgbClr val="207354"/>
@@ -12484,6 +13157,7 @@
               </a:defRPr>
             </a:lvl4pPr>
             <a:lvl5pPr algn="l">
+              <a:buNone/>
               <a:defRPr sz="2475" b="1">
                 <a:solidFill>
                   <a:srgbClr val="207354"/>
@@ -12494,6 +13168,7 @@
               </a:defRPr>
             </a:lvl5pPr>
             <a:lvl6pPr algn="l">
+              <a:buNone/>
               <a:defRPr sz="2475" b="1">
                 <a:solidFill>
                   <a:srgbClr val="207354"/>
@@ -12504,6 +13179,7 @@
               </a:defRPr>
             </a:lvl6pPr>
             <a:lvl7pPr algn="l">
+              <a:buNone/>
               <a:defRPr sz="2475" b="1">
                 <a:solidFill>
                   <a:srgbClr val="207354"/>
@@ -12514,6 +13190,7 @@
               </a:defRPr>
             </a:lvl7pPr>
             <a:lvl8pPr algn="l">
+              <a:buNone/>
               <a:defRPr sz="2475" b="1">
                 <a:solidFill>
                   <a:srgbClr val="207354"/>
@@ -12524,6 +13201,7 @@
               </a:defRPr>
             </a:lvl8pPr>
             <a:lvl9pPr algn="l">
+              <a:buNone/>
               <a:defRPr sz="2475" b="1">
                 <a:solidFill>
                   <a:srgbClr val="207354"/>
@@ -12536,6 +13214,7 @@
           </a:lstStyle>
           <a:p xmlns:a="http://schemas.openxmlformats.org/drawingml/2006/main">
             <a:pPr algn="l">
+              <a:buNone/>
               <a:defRPr sz="2475" b="1">
                 <a:solidFill>
                   <a:srgbClr val="207354"/>
@@ -12603,6 +13282,7 @@
               </a:defRPr>
             </a:defPPr>
             <a:lvl1pPr algn="l">
+              <a:buNone/>
               <a:defRPr sz="2100" b="0">
                 <a:solidFill>
                   <a:srgbClr val="17211C"/>
@@ -12613,6 +13293,7 @@
               </a:defRPr>
             </a:lvl1pPr>
             <a:lvl2pPr algn="l">
+              <a:buNone/>
               <a:defRPr sz="2100" b="0">
                 <a:solidFill>
                   <a:srgbClr val="17211C"/>
@@ -12623,6 +13304,7 @@
               </a:defRPr>
             </a:lvl2pPr>
             <a:lvl3pPr algn="l">
+              <a:buNone/>
               <a:defRPr sz="2100" b="0">
                 <a:solidFill>
                   <a:srgbClr val="17211C"/>
@@ -12633,6 +13315,7 @@
               </a:defRPr>
             </a:lvl3pPr>
             <a:lvl4pPr algn="l">
+              <a:buNone/>
               <a:defRPr sz="2100" b="0">
                 <a:solidFill>
                   <a:srgbClr val="17211C"/>
@@ -12643,6 +13326,7 @@
               </a:defRPr>
             </a:lvl4pPr>
             <a:lvl5pPr algn="l">
+              <a:buNone/>
               <a:defRPr sz="2100" b="0">
                 <a:solidFill>
                   <a:srgbClr val="17211C"/>
@@ -12653,6 +13337,7 @@
               </a:defRPr>
             </a:lvl5pPr>
             <a:lvl6pPr algn="l">
+              <a:buNone/>
               <a:defRPr sz="2100" b="0">
                 <a:solidFill>
                   <a:srgbClr val="17211C"/>
@@ -12663,6 +13348,7 @@
               </a:defRPr>
             </a:lvl6pPr>
             <a:lvl7pPr algn="l">
+              <a:buNone/>
               <a:defRPr sz="2100" b="0">
                 <a:solidFill>
                   <a:srgbClr val="17211C"/>
@@ -12673,6 +13359,7 @@
               </a:defRPr>
             </a:lvl7pPr>
             <a:lvl8pPr algn="l">
+              <a:buNone/>
               <a:defRPr sz="2100" b="0">
                 <a:solidFill>
                   <a:srgbClr val="17211C"/>
@@ -12683,6 +13370,7 @@
               </a:defRPr>
             </a:lvl8pPr>
             <a:lvl9pPr algn="l">
+              <a:buNone/>
               <a:defRPr sz="2100" b="0">
                 <a:solidFill>
                   <a:srgbClr val="17211C"/>
@@ -12695,6 +13383,7 @@
           </a:lstStyle>
           <a:p xmlns:a="http://schemas.openxmlformats.org/drawingml/2006/main">
             <a:pPr algn="l">
+              <a:buNone/>
               <a:defRPr sz="2100" b="0">
                 <a:solidFill>
                   <a:srgbClr val="17211C"/>
@@ -12718,6 +13407,7 @@
           </a:p>
           <a:p xmlns:a="http://schemas.openxmlformats.org/drawingml/2006/main">
             <a:pPr algn="l">
+              <a:buNone/>
               <a:defRPr sz="2100" b="0">
                 <a:solidFill>
                   <a:srgbClr val="17211C"/>
@@ -12741,6 +13431,7 @@
           </a:p>
           <a:p xmlns:a="http://schemas.openxmlformats.org/drawingml/2006/main">
             <a:pPr algn="l">
+              <a:buNone/>
               <a:defRPr sz="2100" b="0">
                 <a:solidFill>
                   <a:srgbClr val="17211C"/>
@@ -12808,6 +13499,7 @@
               </a:defRPr>
             </a:defPPr>
             <a:lvl1pPr algn="l">
+              <a:buNone/>
               <a:defRPr sz="1800" b="1">
                 <a:solidFill>
                   <a:srgbClr val="17211C"/>
@@ -12818,6 +13510,7 @@
               </a:defRPr>
             </a:lvl1pPr>
             <a:lvl2pPr algn="l">
+              <a:buNone/>
               <a:defRPr sz="1800" b="1">
                 <a:solidFill>
                   <a:srgbClr val="17211C"/>
@@ -12828,6 +13521,7 @@
               </a:defRPr>
             </a:lvl2pPr>
             <a:lvl3pPr algn="l">
+              <a:buNone/>
               <a:defRPr sz="1800" b="1">
                 <a:solidFill>
                   <a:srgbClr val="17211C"/>
@@ -12838,6 +13532,7 @@
               </a:defRPr>
             </a:lvl3pPr>
             <a:lvl4pPr algn="l">
+              <a:buNone/>
               <a:defRPr sz="1800" b="1">
                 <a:solidFill>
                   <a:srgbClr val="17211C"/>
@@ -12848,6 +13543,7 @@
               </a:defRPr>
             </a:lvl4pPr>
             <a:lvl5pPr algn="l">
+              <a:buNone/>
               <a:defRPr sz="1800" b="1">
                 <a:solidFill>
                   <a:srgbClr val="17211C"/>
@@ -12858,6 +13554,7 @@
               </a:defRPr>
             </a:lvl5pPr>
             <a:lvl6pPr algn="l">
+              <a:buNone/>
               <a:defRPr sz="1800" b="1">
                 <a:solidFill>
                   <a:srgbClr val="17211C"/>
@@ -12868,6 +13565,7 @@
               </a:defRPr>
             </a:lvl6pPr>
             <a:lvl7pPr algn="l">
+              <a:buNone/>
               <a:defRPr sz="1800" b="1">
                 <a:solidFill>
                   <a:srgbClr val="17211C"/>
@@ -12878,6 +13576,7 @@
               </a:defRPr>
             </a:lvl7pPr>
             <a:lvl8pPr algn="l">
+              <a:buNone/>
               <a:defRPr sz="1800" b="1">
                 <a:solidFill>
                   <a:srgbClr val="17211C"/>
@@ -12888,6 +13587,7 @@
               </a:defRPr>
             </a:lvl8pPr>
             <a:lvl9pPr algn="l">
+              <a:buNone/>
               <a:defRPr sz="1800" b="1">
                 <a:solidFill>
                   <a:srgbClr val="17211C"/>
@@ -12900,6 +13600,7 @@
           </a:lstStyle>
           <a:p xmlns:a="http://schemas.openxmlformats.org/drawingml/2006/main">
             <a:pPr algn="l">
+              <a:buNone/>
               <a:defRPr sz="1800" b="1">
                 <a:solidFill>
                   <a:srgbClr val="17211C"/>
@@ -12967,6 +13668,7 @@
               </a:defRPr>
             </a:defPPr>
             <a:lvl1pPr algn="l">
+              <a:buNone/>
               <a:defRPr sz="1725" b="0">
                 <a:solidFill>
                   <a:srgbClr val="17211C"/>
@@ -12977,6 +13679,7 @@
               </a:defRPr>
             </a:lvl1pPr>
             <a:lvl2pPr algn="l">
+              <a:buNone/>
               <a:defRPr sz="1725" b="0">
                 <a:solidFill>
                   <a:srgbClr val="17211C"/>
@@ -12987,6 +13690,7 @@
               </a:defRPr>
             </a:lvl2pPr>
             <a:lvl3pPr algn="l">
+              <a:buNone/>
               <a:defRPr sz="1725" b="0">
                 <a:solidFill>
                   <a:srgbClr val="17211C"/>
@@ -12997,6 +13701,7 @@
               </a:defRPr>
             </a:lvl3pPr>
             <a:lvl4pPr algn="l">
+              <a:buNone/>
               <a:defRPr sz="1725" b="0">
                 <a:solidFill>
                   <a:srgbClr val="17211C"/>
@@ -13007,6 +13712,7 @@
               </a:defRPr>
             </a:lvl4pPr>
             <a:lvl5pPr algn="l">
+              <a:buNone/>
               <a:defRPr sz="1725" b="0">
                 <a:solidFill>
                   <a:srgbClr val="17211C"/>
@@ -13017,6 +13723,7 @@
               </a:defRPr>
             </a:lvl5pPr>
             <a:lvl6pPr algn="l">
+              <a:buNone/>
               <a:defRPr sz="1725" b="0">
                 <a:solidFill>
                   <a:srgbClr val="17211C"/>
@@ -13027,6 +13734,7 @@
               </a:defRPr>
             </a:lvl6pPr>
             <a:lvl7pPr algn="l">
+              <a:buNone/>
               <a:defRPr sz="1725" b="0">
                 <a:solidFill>
                   <a:srgbClr val="17211C"/>
@@ -13037,6 +13745,7 @@
               </a:defRPr>
             </a:lvl7pPr>
             <a:lvl8pPr algn="l">
+              <a:buNone/>
               <a:defRPr sz="1725" b="0">
                 <a:solidFill>
                   <a:srgbClr val="17211C"/>
@@ -13047,6 +13756,7 @@
               </a:defRPr>
             </a:lvl8pPr>
             <a:lvl9pPr algn="l">
+              <a:buNone/>
               <a:defRPr sz="1725" b="0">
                 <a:solidFill>
                   <a:srgbClr val="17211C"/>
@@ -13059,6 +13769,7 @@
           </a:lstStyle>
           <a:p xmlns:a="http://schemas.openxmlformats.org/drawingml/2006/main">
             <a:pPr algn="l">
+              <a:buNone/>
               <a:defRPr sz="1725" b="0">
                 <a:solidFill>
                   <a:srgbClr val="17211C"/>

</xml_diff>